<commit_message>
v4: single cold start at the origin, warm starts from all neighbours
- The only planned cold start is at phi1 = phi2 = 0 at the smallest d;
  the config cold_start point is removed.
- Each node tries its solved grid neighbours, nearest first, and is
  cold-started only when every neighbour's warm start diverges or fails
  the MAC gate.
- Warm-start attempts are capped at warm_start_max_it Newton iterations
  (default 50; successful ones need at most 29 on a 0.1 rad grid), so a
  failing node no longer burns 500 iterations per neighbour.
- Test grid: 2 extra cold starts instead of 47, same energies everywhere.

Presentation: v4 slides updated for the exact-mode cold start, the
single cold start and the neighbour warm starts; new v4 update slide;
slide 17 figure redrawn as rod shapes.

Co-Authored-By: Claude Opus 5.5 <noreply@anthropic.com>
</commit_message>
<xml_diff>
--- a/presentation/elastica_snap_surface.pptx
+++ b/presentation/elastica_snap_surface.pptx
@@ -25,6 +25,7 @@
     <p:sldId id="266" r:id="rId16"/>
     <p:sldId id="267" r:id="rId17"/>
     <p:sldId id="268" r:id="rId18"/>
+    <p:sldId id="288" r:id="rId39"/>
     <p:sldId id="269" r:id="rId19"/>
     <p:sldId id="270" r:id="rId20"/>
     <p:sldId id="271" r:id="rId21"/>
@@ -169,6 +170,7 @@
             <p14:sldId id="266"/>
             <p14:sldId id="267"/>
             <p14:sldId id="268"/>
+            <p14:sldId id="288"/>
             <p14:sldId id="269"/>
             <p14:sldId id="270"/>
             <p14:sldId id="271"/>
@@ -889,7 +891,7 @@
           <a:p>
             <a:r>
               <a:rPr lang="en-US" dirty="0"/>
-              <a:t>CURRENTv4 uses MAC as a gate: one warm-started attempt, then a MAC comparison against the warm-start field. Below 0.85 the solution is treated as a branch switch and the node is re-solved from the first-mode cold start, which by construction lands on the fundamental branch.</a:t>
+              <a:t>CURRENTv4 uses MAC as a gate. The only planned cold start is at φ₁ = φ₂ = 0 at the smallest d. Every other node tries its solved grid neighbours, nearest first: a warm start capped at 50 Newton iterations, then a MAC comparison against that neighbour's field. Below 0.85, or if Newton fails, the next neighbour is tried. Only when all have failed is the node cold-started: continuation from the exact first clamped mode, from both hump directions, keeping the lower-energy result.</a:t>
             </a:r>
           </a:p>
         </p:txBody>
@@ -976,7 +978,7 @@
           <a:p>
             <a:r>
               <a:rPr lang="en-US" dirty="0"/>
-              <a:t>Both versions share this initial guess. CURRENTv3's solver also carries six alternative modes (sign-flipped, half-amplitude, second harmonic), but the study only ever calls mode 1.</a:t>
+              <a:t>CURRENTv3 still uses the old guess, ramp + A sin(πs/L), which is not admissible: its integral of θ is 2AL/π, so the end starts off the axis. The exact mode is θ = 2 asin(√m sn(4Ks/L | m)) with d/L = 2E/K − 1 and fx = (4K/L)². The figure shows rod shapes, x = ∫cos θ ds and y = ∫sin θ ds, from the real cold start at d = 0.90, φ₁ = 0.60, φ₂ = −0.40: two continuation steps between the exact mode and the target; both branches reach it, and the U = 1.23 one is kept over U = 8.17.</a:t>
             </a:r>
           </a:p>
         </p:txBody>
@@ -6209,7 +6211,7 @@
                   <a:schemeClr val="tx1"/>
                 </a:solidFill>
               </a:rPr>
-              <a:t>Order nodes by distance from the cold-start node (0.9, 0.4, −0.4)</a:t>
+              <a:t>Cold-start once at φ₁ = φ₂ = 0, smallest d; visit nodes by grid distance from it</a:t>
             </a:r>
             <a:endParaRPr lang="en-US" sz="1400" dirty="0"/>
           </a:p>
@@ -6337,7 +6339,7 @@
                   <a:schemeClr val="tx1"/>
                 </a:solidFill>
               </a:rPr>
-              <a:t> from the previously solved node</a:t>
+              <a:t> from a solved grid neighbour, nearest first</a:t>
             </a:r>
             <a:endParaRPr lang="en-US" sz="1400" dirty="0"/>
           </a:p>
@@ -6433,7 +6435,7 @@
                   <a:schemeClr val="tx1"/>
                 </a:solidFill>
               </a:rPr>
-              <a:t>Newton solve (SNES, up to 500 iterations)</a:t>
+              <a:t>Newton solve (SNES, at most 50 iterations)</a:t>
             </a:r>
             <a:endParaRPr lang="en-US" sz="1400" dirty="0"/>
           </a:p>
@@ -6830,7 +6832,7 @@
                   <a:schemeClr val="tx1"/>
                 </a:solidFill>
               </a:rPr>
-              <a:t>Reject. Cold restart from the first-mode guess with no MAC check; if that fails too, the node stays unsolved.</a:t>
+              <a:t>Reject, or Newton failed: try the next neighbour. Only when all have failed: cold start from the exact first mode, continuing the clamp angles (no MAC check).</a:t>
             </a:r>
             <a:endParaRPr lang="en-US" sz="1400" dirty="0"/>
           </a:p>
@@ -6931,7 +6933,7 @@
                   <a:schemeClr val="tx1"/>
                 </a:solidFill>
               </a:rPr>
-              <a:t>Rectilinear (d, φ₁, φ₂) grid split into 6 tetrahedra per cell; parameters scaled to the unit cube</a:t>
+              <a:t>Rectilinear (d, φ₁, φ₂) grid split into 6 tetrahedra per cell; warm starts come from the 26 grid neighbours</a:t>
             </a:r>
             <a:endParaRPr lang="en-US" sz="1300" dirty="0"/>
           </a:p>
@@ -7032,7 +7034,7 @@
                   <a:schemeClr val="tx1"/>
                 </a:solidFill>
               </a:rPr>
-              <a:t>Live NPZ + VTU checkpoints; a resume reloads every stored θ field as a warm-start source</a:t>
+              <a:t>Live NPZ + VTU checkpoints, also on Ctrl-C; a resume reloads every stored θ as a warm-start source</a:t>
             </a:r>
             <a:endParaRPr lang="en-US" sz="1300" dirty="0"/>
           </a:p>
@@ -7243,7 +7245,7 @@
                   <a:schemeClr val="tx1"/>
                 </a:solidFill>
               </a:rPr>
-              <a:t>First-mode cold start keeps Newton on the fundamental branch</a:t>
+              <a:t>Exact first-mode cold start, then continue the clamp angles</a:t>
             </a:r>
             <a:endParaRPr lang="en-US" sz="3000" dirty="0"/>
           </a:p>
@@ -7373,7 +7375,745 @@
                           </a:solidFill>
                           <a:latin typeface="Cambria Math" panose="02040503050406030204" pitchFamily="18" charset="0"/>
                         </a:rPr>
+                        <m:t>=2</m:t>
+                      </m:r>
+                      <m:func>
+                        <m:funcPr>
+                          <m:ctrlPr>
+                            <a:rPr lang="en-US" sz="1600" i="1" dirty="0">
+                              <a:solidFill>
+                                <a:schemeClr val="tx1"/>
+                              </a:solidFill>
+                              <a:latin typeface="Cambria Math" panose="02040503050406030204" pitchFamily="18" charset="0"/>
+                            </a:rPr>
+                          </m:ctrlPr>
+                        </m:funcPr>
+                        <m:fName>
+                          <m:r>
+                            <m:rPr>
+                              <m:sty m:val="p"/>
+                            </m:rPr>
+                            <a:rPr lang="en-US" sz="1600" i="0" dirty="0">
+                              <a:solidFill>
+                                <a:schemeClr val="tx1"/>
+                              </a:solidFill>
+                              <a:latin typeface="Cambria Math" panose="02040503050406030204" pitchFamily="18" charset="0"/>
+                            </a:rPr>
+                            <m:t>arcsin</m:t>
+                          </m:r>
+                        </m:fName>
+                        <m:e>
+                          <m:d>
+                            <m:dPr>
+                              <m:begChr m:val="["/>
+                              <m:endChr m:val="]"/>
+                              <m:ctrlPr>
+                                <a:rPr lang="en-US" sz="1600" i="1" dirty="0">
+                                  <a:solidFill>
+                                    <a:schemeClr val="tx1"/>
+                                  </a:solidFill>
+                                  <a:latin typeface="Cambria Math" panose="02040503050406030204" pitchFamily="18" charset="0"/>
+                                </a:rPr>
+                              </m:ctrlPr>
+                            </m:dPr>
+                            <m:e>
+                              <m:rad>
+                                <m:radPr>
+                                  <m:degHide m:val="on"/>
+                                  <m:ctrlPr>
+                                    <a:rPr lang="en-US" sz="1600" i="1" dirty="0">
+                                      <a:solidFill>
+                                        <a:schemeClr val="tx1"/>
+                                      </a:solidFill>
+                                      <a:latin typeface="Cambria Math" panose="02040503050406030204" pitchFamily="18" charset="0"/>
+                                    </a:rPr>
+                                  </m:ctrlPr>
+                                </m:radPr>
+                                <m:deg/>
+                                <m:e>
+                                  <m:r>
+                                    <a:rPr lang="en-US" sz="1600" i="1" dirty="0">
+                                      <a:solidFill>
+                                        <a:schemeClr val="tx1"/>
+                                      </a:solidFill>
+                                      <a:latin typeface="Cambria Math" panose="02040503050406030204" pitchFamily="18" charset="0"/>
+                                    </a:rPr>
+                                    <m:t>𝑚</m:t>
+                                  </m:r>
+                                </m:e>
+                              </m:rad>
+                              <m:func>
+                                <m:funcPr>
+                                  <m:ctrlPr>
+                                    <a:rPr lang="en-US" sz="1600" i="1" dirty="0">
+                                      <a:solidFill>
+                                        <a:schemeClr val="tx1"/>
+                                      </a:solidFill>
+                                      <a:latin typeface="Cambria Math" panose="02040503050406030204" pitchFamily="18" charset="0"/>
+                                    </a:rPr>
+                                  </m:ctrlPr>
+                                </m:funcPr>
+                                <m:fName>
+                                  <m:r>
+                                    <m:rPr>
+                                      <m:sty m:val="p"/>
+                                    </m:rPr>
+                                    <a:rPr lang="en-US" sz="1600" i="0" dirty="0">
+                                      <a:solidFill>
+                                        <a:schemeClr val="tx1"/>
+                                      </a:solidFill>
+                                      <a:latin typeface="Cambria Math" panose="02040503050406030204" pitchFamily="18" charset="0"/>
+                                    </a:rPr>
+                                    <m:t>sn</m:t>
+                                  </m:r>
+                                </m:fName>
+                                <m:e>
+                                  <m:d>
+                                    <m:dPr>
+                                      <m:ctrlPr>
+                                        <a:rPr lang="en-US" sz="1600" i="1" dirty="0">
+                                          <a:solidFill>
+                                            <a:schemeClr val="tx1"/>
+                                          </a:solidFill>
+                                          <a:latin typeface="Cambria Math" panose="02040503050406030204" pitchFamily="18" charset="0"/>
+                                        </a:rPr>
+                                      </m:ctrlPr>
+                                    </m:dPr>
+                                    <m:e>
+                                      <m:r>
+                                        <a:rPr lang="en-US" sz="1600" i="0" dirty="0">
+                                          <a:solidFill>
+                                            <a:schemeClr val="tx1"/>
+                                          </a:solidFill>
+                                          <a:latin typeface="Cambria Math" panose="02040503050406030204" pitchFamily="18" charset="0"/>
+                                        </a:rPr>
+                                        <m:t>4</m:t>
+                                      </m:r>
+                                      <m:r>
+                                        <a:rPr lang="en-US" sz="1600" i="1" dirty="0">
+                                          <a:solidFill>
+                                            <a:schemeClr val="tx1"/>
+                                          </a:solidFill>
+                                          <a:latin typeface="Cambria Math" panose="02040503050406030204" pitchFamily="18" charset="0"/>
+                                        </a:rPr>
+                                        <m:t>𝐾</m:t>
+                                      </m:r>
+                                      <m:r>
+                                        <a:rPr lang="en-US" sz="1600" i="1" dirty="0">
+                                          <a:solidFill>
+                                            <a:schemeClr val="tx1"/>
+                                          </a:solidFill>
+                                          <a:latin typeface="Cambria Math" panose="02040503050406030204" pitchFamily="18" charset="0"/>
+                                        </a:rPr>
+                                        <m:t>𝑠</m:t>
+                                      </m:r>
+                                      <m:r>
+                                        <a:rPr lang="en-US" sz="1600" i="0" dirty="0">
+                                          <a:solidFill>
+                                            <a:schemeClr val="tx1"/>
+                                          </a:solidFill>
+                                          <a:latin typeface="Cambria Math" panose="02040503050406030204" pitchFamily="18" charset="0"/>
+                                        </a:rPr>
+                                        <m:t>/</m:t>
+                                      </m:r>
+                                      <m:r>
+                                        <a:rPr lang="en-US" sz="1600" i="1" dirty="0">
+                                          <a:solidFill>
+                                            <a:schemeClr val="tx1"/>
+                                          </a:solidFill>
+                                          <a:latin typeface="Cambria Math" panose="02040503050406030204" pitchFamily="18" charset="0"/>
+                                        </a:rPr>
+                                        <m:t>𝐿</m:t>
+                                      </m:r>
+                                      <m:r>
+                                        <a:rPr lang="en-US" sz="1600" i="0" dirty="0">
+                                          <a:solidFill>
+                                            <a:schemeClr val="tx1"/>
+                                          </a:solidFill>
+                                          <a:latin typeface="Cambria Math" panose="02040503050406030204" pitchFamily="18" charset="0"/>
+                                        </a:rPr>
+                                        <m:t> | </m:t>
+                                      </m:r>
+                                      <m:r>
+                                        <a:rPr lang="en-US" sz="1600" i="1" dirty="0">
+                                          <a:solidFill>
+                                            <a:schemeClr val="tx1"/>
+                                          </a:solidFill>
+                                          <a:latin typeface="Cambria Math" panose="02040503050406030204" pitchFamily="18" charset="0"/>
+                                        </a:rPr>
+                                        <m:t>𝑚</m:t>
+                                      </m:r>
+                                    </m:e>
+                                  </m:d>
+                                </m:e>
+                              </m:func>
+                            </m:e>
+                          </m:d>
+                        </m:e>
+                      </m:func>
+                      <m:r>
+                        <a:rPr lang="en-US" sz="1600" i="0" dirty="0">
+                          <a:solidFill>
+                            <a:schemeClr val="tx1"/>
+                          </a:solidFill>
+                          <a:latin typeface="Cambria Math" panose="02040503050406030204" pitchFamily="18" charset="0"/>
+                        </a:rPr>
+                        <m:t>,     </m:t>
+                      </m:r>
+                      <m:r>
+                        <a:rPr lang="en-US" sz="1600" i="1" dirty="0">
+                          <a:solidFill>
+                            <a:schemeClr val="tx1"/>
+                          </a:solidFill>
+                          <a:latin typeface="Cambria Math" panose="02040503050406030204" pitchFamily="18" charset="0"/>
+                        </a:rPr>
+                        <m:t>𝑑</m:t>
+                      </m:r>
+                      <m:r>
+                        <a:rPr lang="en-US" sz="1600" i="0" dirty="0">
+                          <a:solidFill>
+                            <a:schemeClr val="tx1"/>
+                          </a:solidFill>
+                          <a:latin typeface="Cambria Math" panose="02040503050406030204" pitchFamily="18" charset="0"/>
+                        </a:rPr>
+                        <m:t>/</m:t>
+                      </m:r>
+                      <m:r>
+                        <a:rPr lang="en-US" sz="1600" i="1" dirty="0">
+                          <a:solidFill>
+                            <a:schemeClr val="tx1"/>
+                          </a:solidFill>
+                          <a:latin typeface="Cambria Math" panose="02040503050406030204" pitchFamily="18" charset="0"/>
+                        </a:rPr>
+                        <m:t>𝐿</m:t>
+                      </m:r>
+                      <m:r>
+                        <a:rPr lang="en-US" sz="1600" i="0" dirty="0">
+                          <a:solidFill>
+                            <a:schemeClr val="tx1"/>
+                          </a:solidFill>
+                          <a:latin typeface="Cambria Math" panose="02040503050406030204" pitchFamily="18" charset="0"/>
+                        </a:rPr>
+                        <m:t>=2</m:t>
+                      </m:r>
+                      <m:r>
+                        <a:rPr lang="en-US" sz="1600" i="1" dirty="0">
+                          <a:solidFill>
+                            <a:schemeClr val="tx1"/>
+                          </a:solidFill>
+                          <a:latin typeface="Cambria Math" panose="02040503050406030204" pitchFamily="18" charset="0"/>
+                        </a:rPr>
+                        <m:t>𝐸</m:t>
+                      </m:r>
+                      <m:d>
+                        <m:dPr>
+                          <m:ctrlPr>
+                            <a:rPr lang="en-US" sz="1600" i="1" dirty="0">
+                              <a:solidFill>
+                                <a:schemeClr val="tx1"/>
+                              </a:solidFill>
+                              <a:latin typeface="Cambria Math" panose="02040503050406030204" pitchFamily="18" charset="0"/>
+                            </a:rPr>
+                          </m:ctrlPr>
+                        </m:dPr>
+                        <m:e>
+                          <m:r>
+                            <a:rPr lang="en-US" sz="1600" i="1" dirty="0">
+                              <a:solidFill>
+                                <a:schemeClr val="tx1"/>
+                              </a:solidFill>
+                              <a:latin typeface="Cambria Math" panose="02040503050406030204" pitchFamily="18" charset="0"/>
+                            </a:rPr>
+                            <m:t>𝑚</m:t>
+                          </m:r>
+                        </m:e>
+                      </m:d>
+                      <m:r>
+                        <a:rPr lang="en-US" sz="1600" i="0" dirty="0">
+                          <a:solidFill>
+                            <a:schemeClr val="tx1"/>
+                          </a:solidFill>
+                          <a:latin typeface="Cambria Math" panose="02040503050406030204" pitchFamily="18" charset="0"/>
+                        </a:rPr>
+                        <m:t>/</m:t>
+                      </m:r>
+                      <m:r>
+                        <a:rPr lang="en-US" sz="1600" i="1" dirty="0">
+                          <a:solidFill>
+                            <a:schemeClr val="tx1"/>
+                          </a:solidFill>
+                          <a:latin typeface="Cambria Math" panose="02040503050406030204" pitchFamily="18" charset="0"/>
+                        </a:rPr>
+                        <m:t>𝐾</m:t>
+                      </m:r>
+                      <m:d>
+                        <m:dPr>
+                          <m:ctrlPr>
+                            <a:rPr lang="en-US" sz="1600" i="1" dirty="0">
+                              <a:solidFill>
+                                <a:schemeClr val="tx1"/>
+                              </a:solidFill>
+                              <a:latin typeface="Cambria Math" panose="02040503050406030204" pitchFamily="18" charset="0"/>
+                            </a:rPr>
+                          </m:ctrlPr>
+                        </m:dPr>
+                        <m:e>
+                          <m:r>
+                            <a:rPr lang="en-US" sz="1600" i="1" dirty="0">
+                              <a:solidFill>
+                                <a:schemeClr val="tx1"/>
+                              </a:solidFill>
+                              <a:latin typeface="Cambria Math" panose="02040503050406030204" pitchFamily="18" charset="0"/>
+                            </a:rPr>
+                            <m:t>𝑚</m:t>
+                          </m:r>
+                        </m:e>
+                      </m:d>
+                      <m:r>
+                        <a:rPr lang="en-US" sz="1600" i="0" dirty="0">
+                          <a:solidFill>
+                            <a:schemeClr val="tx1"/>
+                          </a:solidFill>
+                          <a:latin typeface="Cambria Math" panose="02040503050406030204" pitchFamily="18" charset="0"/>
+                        </a:rPr>
+                        <m:t>−1,     </m:t>
+                      </m:r>
+                      <m:sSub>
+                        <m:sSubPr>
+                          <m:ctrlPr>
+                            <a:rPr lang="en-US" sz="1600" i="1" dirty="0">
+                              <a:solidFill>
+                                <a:schemeClr val="tx1"/>
+                              </a:solidFill>
+                              <a:latin typeface="Cambria Math" panose="02040503050406030204" pitchFamily="18" charset="0"/>
+                            </a:rPr>
+                          </m:ctrlPr>
+                        </m:sSubPr>
+                        <m:e>
+                          <m:r>
+                            <a:rPr lang="en-US" sz="1600" i="1" dirty="0">
+                              <a:solidFill>
+                                <a:schemeClr val="tx1"/>
+                              </a:solidFill>
+                              <a:latin typeface="Cambria Math" panose="02040503050406030204" pitchFamily="18" charset="0"/>
+                            </a:rPr>
+                            <m:t>𝑓</m:t>
+                          </m:r>
+                        </m:e>
+                        <m:sub>
+                          <m:r>
+                            <a:rPr lang="en-US" sz="1600" i="1" dirty="0">
+                              <a:solidFill>
+                                <a:schemeClr val="tx1"/>
+                              </a:solidFill>
+                              <a:latin typeface="Cambria Math" panose="02040503050406030204" pitchFamily="18" charset="0"/>
+                            </a:rPr>
+                            <m:t>𝑥</m:t>
+                          </m:r>
+                        </m:sub>
+                      </m:sSub>
+                      <m:r>
+                        <a:rPr lang="en-US" sz="1600" i="0" dirty="0">
+                          <a:solidFill>
+                            <a:schemeClr val="tx1"/>
+                          </a:solidFill>
+                          <a:latin typeface="Cambria Math" panose="02040503050406030204" pitchFamily="18" charset="0"/>
+                        </a:rPr>
                         <m:t>=</m:t>
+                      </m:r>
+                      <m:sSup>
+                        <m:sSupPr>
+                          <m:ctrlPr>
+                            <a:rPr lang="en-US" sz="1600" i="1" dirty="0">
+                              <a:solidFill>
+                                <a:schemeClr val="tx1"/>
+                              </a:solidFill>
+                              <a:latin typeface="Cambria Math" panose="02040503050406030204" pitchFamily="18" charset="0"/>
+                            </a:rPr>
+                          </m:ctrlPr>
+                        </m:sSupPr>
+                        <m:e>
+                          <m:d>
+                            <m:dPr>
+                              <m:ctrlPr>
+                                <a:rPr lang="en-US" sz="1600" i="1" dirty="0">
+                                  <a:solidFill>
+                                    <a:schemeClr val="tx1"/>
+                                  </a:solidFill>
+                                  <a:latin typeface="Cambria Math" panose="02040503050406030204" pitchFamily="18" charset="0"/>
+                                </a:rPr>
+                              </m:ctrlPr>
+                            </m:dPr>
+                            <m:e>
+                              <m:r>
+                                <a:rPr lang="en-US" sz="1600" i="0" dirty="0">
+                                  <a:solidFill>
+                                    <a:schemeClr val="tx1"/>
+                                  </a:solidFill>
+                                  <a:latin typeface="Cambria Math" panose="02040503050406030204" pitchFamily="18" charset="0"/>
+                                </a:rPr>
+                                <m:t>4</m:t>
+                              </m:r>
+                              <m:r>
+                                <a:rPr lang="en-US" sz="1600" i="1" dirty="0">
+                                  <a:solidFill>
+                                    <a:schemeClr val="tx1"/>
+                                  </a:solidFill>
+                                  <a:latin typeface="Cambria Math" panose="02040503050406030204" pitchFamily="18" charset="0"/>
+                                </a:rPr>
+                                <m:t>𝐾</m:t>
+                              </m:r>
+                              <m:r>
+                                <a:rPr lang="en-US" sz="1600" i="0" dirty="0">
+                                  <a:solidFill>
+                                    <a:schemeClr val="tx1"/>
+                                  </a:solidFill>
+                                  <a:latin typeface="Cambria Math" panose="02040503050406030204" pitchFamily="18" charset="0"/>
+                                </a:rPr>
+                                <m:t>/</m:t>
+                              </m:r>
+                              <m:r>
+                                <a:rPr lang="en-US" sz="1600" i="1" dirty="0">
+                                  <a:solidFill>
+                                    <a:schemeClr val="tx1"/>
+                                  </a:solidFill>
+                                  <a:latin typeface="Cambria Math" panose="02040503050406030204" pitchFamily="18" charset="0"/>
+                                </a:rPr>
+                                <m:t>𝐿</m:t>
+                              </m:r>
+                            </m:e>
+                          </m:d>
+                        </m:e>
+                        <m:sup>
+                          <m:r>
+                            <a:rPr lang="en-US" sz="1600" i="0" dirty="0">
+                              <a:solidFill>
+                                <a:schemeClr val="tx1"/>
+                              </a:solidFill>
+                              <a:latin typeface="Cambria Math" panose="02040503050406030204" pitchFamily="18" charset="0"/>
+                            </a:rPr>
+                            <m:t>2</m:t>
+                          </m:r>
+                        </m:sup>
+                      </m:sSup>
+                    </m:oMath>
+                  </m:oMathPara>
+                </a14:m>
+                <a:endParaRPr lang="en-US" sz="1600" dirty="0"/>
+              </a:p>
+            </p:txBody>
+          </p:sp>
+        </mc:Choice>
+        <mc:Fallback xmlns="">
+          <p:sp>
+            <p:nvSpPr>
+              <p:cNvPr id="4" name="latex-cold"/>
+              <p:cNvSpPr txBox="1">
+                <a:spLocks noRot="1" noChangeAspect="1" noMove="1" noResize="1" noEditPoints="1" noAdjustHandles="1" noChangeArrowheads="1" noChangeShapeType="1" noTextEdit="1"/>
+              </p:cNvSpPr>
+              <p:nvPr/>
+            </p:nvSpPr>
+            <p:spPr>
+              <a:xfrm>
+                <a:off x="822960" y="1656984"/>
+                <a:ext cx="10607040" cy="435072"/>
+              </a:xfrm>
+              <a:prstGeom prst="rect">
+                <a:avLst/>
+              </a:prstGeom>
+              <a:blipFill>
+                <a:blip r:embed="rId3"/>
+                <a:stretch>
+                  <a:fillRect/>
+                </a:stretch>
+              </a:blipFill>
+              <a:ln/>
+            </p:spPr>
+            <p:txBody>
+              <a:bodyPr/>
+              <a:lstStyle/>
+              <a:p>
+                <a:r>
+                  <a:rPr lang="en-IN">
+                    <a:noFill/>
+                  </a:rPr>
+                  <a:t> </a:t>
+                </a:r>
+              </a:p>
+            </p:txBody>
+          </p:sp>
+        </mc:Fallback>
+      </mc:AlternateContent>
+      <p:pic>
+        <p:nvPicPr>
+          <p:cNvPr id="5" name="figure-135" descr="Rod shapes during the cold start at d = 0.90, φ1 = 0.60, φ2 = -0.40: exact first mode, two continuation steps, and the kept and discarded branches"/>
+          <p:cNvPicPr>
+            <a:picLocks noChangeAspect="1"/>
+          </p:cNvPicPr>
+          <p:nvPr/>
+        </p:nvPicPr>
+        <p:blipFill>
+          <a:blip r:embed="rId4"/>
+          <a:stretch>
+            <a:fillRect/>
+          </a:stretch>
+        </p:blipFill>
+        <p:spPr>
+          <a:xfrm>
+            <a:off x="457200" y="2560320"/>
+            <a:ext cx="5394960" cy="3596640"/>
+          </a:xfrm>
+          <a:prstGeom prst="rect">
+            <a:avLst/>
+          </a:prstGeom>
+        </p:spPr>
+      </p:pic>
+      <p:sp>
+        <p:nvSpPr>
+          <p:cNvPr id="6" name="text-136"/>
+          <p:cNvSpPr txBox="1"/>
+          <p:nvPr/>
+        </p:nvSpPr>
+        <p:spPr>
+          <a:xfrm>
+            <a:off x="6217920" y="2606040"/>
+            <a:ext cx="5394960" cy="365760"/>
+          </a:xfrm>
+          <a:prstGeom prst="rect">
+            <a:avLst/>
+          </a:prstGeom>
+          <a:noFill/>
+          <a:ln/>
+        </p:spPr>
+        <p:txBody>
+          <a:bodyPr wrap="square" lIns="0" tIns="0" rIns="0" bIns="0" rtlCol="0" anchor="t"/>
+          <a:lstStyle/>
+          <a:p>
+            <a:pPr marL="0" indent="0">
+              <a:buNone/>
+            </a:pPr>
+            <a:r>
+              <a:rPr lang="en-US" sz="1600" b="1" dirty="0">
+                <a:solidFill>
+                  <a:schemeClr val="accent1"/>
+                </a:solidFill>
+              </a:rPr>
+              <a:t>Predictor for each continuation step</a:t>
+            </a:r>
+            <a:endParaRPr lang="en-US" sz="1600" dirty="0"/>
+          </a:p>
+        </p:txBody>
+      </p:sp>
+      <mc:AlternateContent xmlns:mc="http://schemas.openxmlformats.org/markup-compatibility/2006" xmlns:a14="http://schemas.microsoft.com/office/drawing/2010/main">
+        <mc:Choice Requires="a14">
+          <p:sp>
+            <p:nvSpPr>
+              <p:cNvPr id="7" name="latex-amp"/>
+              <p:cNvSpPr txBox="1"/>
+              <p:nvPr/>
+            </p:nvSpPr>
+            <p:spPr>
+              <a:xfrm>
+                <a:off x="6217920" y="3017520"/>
+                <a:ext cx="5425135" cy="662208"/>
+              </a:xfrm>
+              <a:prstGeom prst="rect">
+                <a:avLst/>
+              </a:prstGeom>
+              <a:noFill/>
+              <a:ln/>
+            </p:spPr>
+            <p:txBody>
+              <a:bodyPr wrap="square" lIns="0" tIns="0" rIns="0" bIns="0" rtlCol="0" anchor="ctr">
+                <a:noAutofit/>
+              </a:bodyPr>
+              <a:lstStyle/>
+              <a:p>
+                <a:pPr marL="0" indent="0">
+                  <a:buNone/>
+                </a:pPr>
+                <a14:m>
+                  <m:oMathPara xmlns:m="http://schemas.openxmlformats.org/officeDocument/2006/math">
+                    <m:oMath>
+                      <m:sSubSup>
+                        <m:sSubSupPr>
+                          <m:ctrlPr>
+                            <a:rPr lang="en-US" sz="1600" i="1" dirty="0">
+                              <a:solidFill>
+                                <a:schemeClr val="tx1"/>
+                              </a:solidFill>
+                              <a:latin typeface="Cambria Math" panose="02040503050406030204" pitchFamily="18" charset="0"/>
+                            </a:rPr>
+                          </m:ctrlPr>
+                        </m:sSubSupPr>
+                        <m:e>
+                          <m:r>
+                            <a:rPr lang="en-US" sz="1600" i="1" dirty="0">
+                              <a:solidFill>
+                                <a:schemeClr val="tx1"/>
+                              </a:solidFill>
+                              <a:latin typeface="Cambria Math" panose="02040503050406030204" pitchFamily="18" charset="0"/>
+                            </a:rPr>
+                            <m:t>𝜃</m:t>
+                          </m:r>
+                        </m:e>
+                        <m:sub>
+                          <m:r>
+                            <a:rPr lang="en-US" sz="1600" i="0" dirty="0">
+                              <a:solidFill>
+                                <a:schemeClr val="tx1"/>
+                              </a:solidFill>
+                              <a:latin typeface="Cambria Math" panose="02040503050406030204" pitchFamily="18" charset="0"/>
+                            </a:rPr>
+                            <m:t>0</m:t>
+                          </m:r>
+                        </m:sub>
+                        <m:sup>
+                          <m:d>
+                            <m:dPr>
+                              <m:ctrlPr>
+                                <a:rPr lang="en-US" sz="1600" i="1" dirty="0">
+                                  <a:solidFill>
+                                    <a:schemeClr val="tx1"/>
+                                  </a:solidFill>
+                                  <a:latin typeface="Cambria Math" panose="02040503050406030204" pitchFamily="18" charset="0"/>
+                                </a:rPr>
+                              </m:ctrlPr>
+                            </m:dPr>
+                            <m:e>
+                              <m:r>
+                                <a:rPr lang="en-US" sz="1600" i="1" dirty="0">
+                                  <a:solidFill>
+                                    <a:schemeClr val="tx1"/>
+                                  </a:solidFill>
+                                  <a:latin typeface="Cambria Math" panose="02040503050406030204" pitchFamily="18" charset="0"/>
+                                </a:rPr>
+                                <m:t>𝑘</m:t>
+                              </m:r>
+                              <m:r>
+                                <a:rPr lang="en-US" sz="1600" i="0" dirty="0">
+                                  <a:solidFill>
+                                    <a:schemeClr val="tx1"/>
+                                  </a:solidFill>
+                                  <a:latin typeface="Cambria Math" panose="02040503050406030204" pitchFamily="18" charset="0"/>
+                                </a:rPr>
+                                <m:t>+1</m:t>
+                              </m:r>
+                            </m:e>
+                          </m:d>
+                        </m:sup>
+                      </m:sSubSup>
+                      <m:d>
+                        <m:dPr>
+                          <m:ctrlPr>
+                            <a:rPr lang="en-US" sz="1600" i="1" dirty="0">
+                              <a:solidFill>
+                                <a:schemeClr val="tx1"/>
+                              </a:solidFill>
+                              <a:latin typeface="Cambria Math" panose="02040503050406030204" pitchFamily="18" charset="0"/>
+                            </a:rPr>
+                          </m:ctrlPr>
+                        </m:dPr>
+                        <m:e>
+                          <m:r>
+                            <a:rPr lang="en-US" sz="1600" i="1" dirty="0">
+                              <a:solidFill>
+                                <a:schemeClr val="tx1"/>
+                              </a:solidFill>
+                              <a:latin typeface="Cambria Math" panose="02040503050406030204" pitchFamily="18" charset="0"/>
+                            </a:rPr>
+                            <m:t>𝑠</m:t>
+                          </m:r>
+                        </m:e>
+                      </m:d>
+                      <m:r>
+                        <a:rPr lang="en-US" sz="1600" i="0" dirty="0">
+                          <a:solidFill>
+                            <a:schemeClr val="tx1"/>
+                          </a:solidFill>
+                          <a:latin typeface="Cambria Math" panose="02040503050406030204" pitchFamily="18" charset="0"/>
+                        </a:rPr>
+                        <m:t>=</m:t>
+                      </m:r>
+                      <m:sSup>
+                        <m:sSupPr>
+                          <m:ctrlPr>
+                            <a:rPr lang="en-US" sz="1600" i="1" dirty="0">
+                              <a:solidFill>
+                                <a:schemeClr val="tx1"/>
+                              </a:solidFill>
+                              <a:latin typeface="Cambria Math" panose="02040503050406030204" pitchFamily="18" charset="0"/>
+                            </a:rPr>
+                          </m:ctrlPr>
+                        </m:sSupPr>
+                        <m:e>
+                          <m:r>
+                            <a:rPr lang="en-US" sz="1600" i="1" dirty="0">
+                              <a:solidFill>
+                                <a:schemeClr val="tx1"/>
+                              </a:solidFill>
+                              <a:latin typeface="Cambria Math" panose="02040503050406030204" pitchFamily="18" charset="0"/>
+                            </a:rPr>
+                            <m:t>𝜃</m:t>
+                          </m:r>
+                        </m:e>
+                        <m:sup>
+                          <m:d>
+                            <m:dPr>
+                              <m:ctrlPr>
+                                <a:rPr lang="en-US" sz="1600" i="1" dirty="0">
+                                  <a:solidFill>
+                                    <a:schemeClr val="tx1"/>
+                                  </a:solidFill>
+                                  <a:latin typeface="Cambria Math" panose="02040503050406030204" pitchFamily="18" charset="0"/>
+                                </a:rPr>
+                              </m:ctrlPr>
+                            </m:dPr>
+                            <m:e>
+                              <m:r>
+                                <a:rPr lang="en-US" sz="1600" i="1" dirty="0">
+                                  <a:solidFill>
+                                    <a:schemeClr val="tx1"/>
+                                  </a:solidFill>
+                                  <a:latin typeface="Cambria Math" panose="02040503050406030204" pitchFamily="18" charset="0"/>
+                                </a:rPr>
+                                <m:t>𝑘</m:t>
+                              </m:r>
+                            </m:e>
+                          </m:d>
+                        </m:sup>
+                      </m:sSup>
+                      <m:d>
+                        <m:dPr>
+                          <m:ctrlPr>
+                            <a:rPr lang="en-US" sz="1600" i="1" dirty="0">
+                              <a:solidFill>
+                                <a:schemeClr val="tx1"/>
+                              </a:solidFill>
+                              <a:latin typeface="Cambria Math" panose="02040503050406030204" pitchFamily="18" charset="0"/>
+                            </a:rPr>
+                          </m:ctrlPr>
+                        </m:dPr>
+                        <m:e>
+                          <m:r>
+                            <a:rPr lang="en-US" sz="1600" i="1" dirty="0">
+                              <a:solidFill>
+                                <a:schemeClr val="tx1"/>
+                              </a:solidFill>
+                              <a:latin typeface="Cambria Math" panose="02040503050406030204" pitchFamily="18" charset="0"/>
+                            </a:rPr>
+                            <m:t>𝑠</m:t>
+                          </m:r>
+                        </m:e>
+                      </m:d>
+                      <m:r>
+                        <a:rPr lang="en-US" sz="1600" i="0" dirty="0">
+                          <a:solidFill>
+                            <a:schemeClr val="tx1"/>
+                          </a:solidFill>
+                          <a:latin typeface="Cambria Math" panose="02040503050406030204" pitchFamily="18" charset="0"/>
+                        </a:rPr>
+                        <m:t>+Δ</m:t>
                       </m:r>
                       <m:sSub>
                         <m:sSubPr>
@@ -7409,15 +8149,6 @@
                           </m:r>
                         </m:sub>
                       </m:sSub>
-                      <m:r>
-                        <a:rPr lang="en-US" sz="1600" i="0" dirty="0">
-                          <a:solidFill>
-                            <a:schemeClr val="tx1"/>
-                          </a:solidFill>
-                          <a:latin typeface="Cambria Math" panose="02040503050406030204" pitchFamily="18" charset="0"/>
-                        </a:rPr>
-                        <m:t>+</m:t>
-                      </m:r>
                       <m:d>
                         <m:dPr>
                           <m:ctrlPr>
@@ -7430,8 +8161,17 @@
                           </m:ctrlPr>
                         </m:dPr>
                         <m:e>
-                          <m:sSub>
-                            <m:sSubPr>
+                          <m:r>
+                            <a:rPr lang="en-US" sz="1600" i="0" dirty="0">
+                              <a:solidFill>
+                                <a:schemeClr val="tx1"/>
+                              </a:solidFill>
+                              <a:latin typeface="Cambria Math" panose="02040503050406030204" pitchFamily="18" charset="0"/>
+                            </a:rPr>
+                            <m:t>1−</m:t>
+                          </m:r>
+                          <m:f>
+                            <m:fPr>
                               <m:ctrlPr>
                                 <a:rPr lang="en-US" sz="1600" i="1" dirty="0">
                                   <a:solidFill>
@@ -7440,8 +8180,8 @@
                                   <a:latin typeface="Cambria Math" panose="02040503050406030204" pitchFamily="18" charset="0"/>
                                 </a:rPr>
                               </m:ctrlPr>
-                            </m:sSubPr>
-                            <m:e>
+                            </m:fPr>
+                            <m:num>
                               <m:r>
                                 <a:rPr lang="en-US" sz="1600" i="1" dirty="0">
                                   <a:solidFill>
@@ -7449,21 +8189,55 @@
                                   </a:solidFill>
                                   <a:latin typeface="Cambria Math" panose="02040503050406030204" pitchFamily="18" charset="0"/>
                                 </a:rPr>
-                                <m:t>𝜑</m:t>
+                                <m:t>𝑠</m:t>
                               </m:r>
-                            </m:e>
-                            <m:sub>
+                            </m:num>
+                            <m:den>
                               <m:r>
-                                <a:rPr lang="en-US" sz="1600" i="0" dirty="0">
+                                <a:rPr lang="en-US" sz="1600" i="1" dirty="0">
                                   <a:solidFill>
                                     <a:schemeClr val="tx1"/>
                                   </a:solidFill>
                                   <a:latin typeface="Cambria Math" panose="02040503050406030204" pitchFamily="18" charset="0"/>
                                 </a:rPr>
-                                <m:t>2</m:t>
+                                <m:t>𝐿</m:t>
                               </m:r>
-                            </m:sub>
-                          </m:sSub>
+                            </m:den>
+                          </m:f>
+                        </m:e>
+                      </m:d>
+                      <m:r>
+                        <a:rPr lang="en-US" sz="1600" i="0" dirty="0">
+                          <a:solidFill>
+                            <a:schemeClr val="tx1"/>
+                          </a:solidFill>
+                          <a:latin typeface="Cambria Math" panose="02040503050406030204" pitchFamily="18" charset="0"/>
+                        </a:rPr>
+                        <m:t>+Δ</m:t>
+                      </m:r>
+                      <m:sSub>
+                        <m:sSubPr>
+                          <m:ctrlPr>
+                            <a:rPr lang="en-US" sz="1600" i="1" dirty="0">
+                              <a:solidFill>
+                                <a:schemeClr val="tx1"/>
+                              </a:solidFill>
+                              <a:latin typeface="Cambria Math" panose="02040503050406030204" pitchFamily="18" charset="0"/>
+                            </a:rPr>
+                          </m:ctrlPr>
+                        </m:sSubPr>
+                        <m:e>
+                          <m:r>
+                            <a:rPr lang="en-US" sz="1600" i="1" dirty="0">
+                              <a:solidFill>
+                                <a:schemeClr val="tx1"/>
+                              </a:solidFill>
+                              <a:latin typeface="Cambria Math" panose="02040503050406030204" pitchFamily="18" charset="0"/>
+                            </a:rPr>
+                            <m:t>𝜑</m:t>
+                          </m:r>
+                        </m:e>
+                        <m:sub>
                           <m:r>
                             <a:rPr lang="en-US" sz="1600" i="0" dirty="0">
                               <a:solidFill>
@@ -7471,44 +8245,10 @@
                               </a:solidFill>
                               <a:latin typeface="Cambria Math" panose="02040503050406030204" pitchFamily="18" charset="0"/>
                             </a:rPr>
-                            <m:t>−</m:t>
+                            <m:t>2</m:t>
                           </m:r>
-                          <m:sSub>
-                            <m:sSubPr>
-                              <m:ctrlPr>
-                                <a:rPr lang="en-US" sz="1600" i="1" dirty="0">
-                                  <a:solidFill>
-                                    <a:schemeClr val="tx1"/>
-                                  </a:solidFill>
-                                  <a:latin typeface="Cambria Math" panose="02040503050406030204" pitchFamily="18" charset="0"/>
-                                </a:rPr>
-                              </m:ctrlPr>
-                            </m:sSubPr>
-                            <m:e>
-                              <m:r>
-                                <a:rPr lang="en-US" sz="1600" i="1" dirty="0">
-                                  <a:solidFill>
-                                    <a:schemeClr val="tx1"/>
-                                  </a:solidFill>
-                                  <a:latin typeface="Cambria Math" panose="02040503050406030204" pitchFamily="18" charset="0"/>
-                                </a:rPr>
-                                <m:t>𝜑</m:t>
-                              </m:r>
-                            </m:e>
-                            <m:sub>
-                              <m:r>
-                                <a:rPr lang="en-US" sz="1600" i="0" dirty="0">
-                                  <a:solidFill>
-                                    <a:schemeClr val="tx1"/>
-                                  </a:solidFill>
-                                  <a:latin typeface="Cambria Math" panose="02040503050406030204" pitchFamily="18" charset="0"/>
-                                </a:rPr>
-                                <m:t>1</m:t>
-                              </m:r>
-                            </m:sub>
-                          </m:sSub>
-                        </m:e>
-                      </m:d>
+                        </m:sub>
+                      </m:sSub>
                       <m:f>
                         <m:fPr>
                           <m:ctrlPr>
@@ -7540,671 +8280,6 @@
                               <a:latin typeface="Cambria Math" panose="02040503050406030204" pitchFamily="18" charset="0"/>
                             </a:rPr>
                             <m:t>𝐿</m:t>
-                          </m:r>
-                        </m:den>
-                      </m:f>
-                      <m:r>
-                        <a:rPr lang="en-US" sz="1600" i="0" dirty="0">
-                          <a:solidFill>
-                            <a:schemeClr val="tx1"/>
-                          </a:solidFill>
-                          <a:latin typeface="Cambria Math" panose="02040503050406030204" pitchFamily="18" charset="0"/>
-                        </a:rPr>
-                        <m:t>+</m:t>
-                      </m:r>
-                      <m:r>
-                        <a:rPr lang="en-US" sz="1600" i="1" dirty="0">
-                          <a:solidFill>
-                            <a:schemeClr val="tx1"/>
-                          </a:solidFill>
-                          <a:latin typeface="Cambria Math" panose="02040503050406030204" pitchFamily="18" charset="0"/>
-                        </a:rPr>
-                        <m:t>𝐴</m:t>
-                      </m:r>
-                      <m:func>
-                        <m:funcPr>
-                          <m:ctrlPr>
-                            <a:rPr lang="en-US" sz="1600" i="0" dirty="0">
-                              <a:solidFill>
-                                <a:schemeClr val="tx1"/>
-                              </a:solidFill>
-                              <a:latin typeface="Cambria Math" panose="02040503050406030204" pitchFamily="18" charset="0"/>
-                            </a:rPr>
-                          </m:ctrlPr>
-                        </m:funcPr>
-                        <m:fName>
-                          <m:r>
-                            <m:rPr>
-                              <m:sty m:val="p"/>
-                            </m:rPr>
-                            <a:rPr lang="en-US" sz="1600" i="0" dirty="0">
-                              <a:solidFill>
-                                <a:schemeClr val="tx1"/>
-                              </a:solidFill>
-                              <a:latin typeface="Cambria Math" panose="02040503050406030204" pitchFamily="18" charset="0"/>
-                            </a:rPr>
-                            <m:t>sin</m:t>
-                          </m:r>
-                        </m:fName>
-                        <m:e>
-                          <m:f>
-                            <m:fPr>
-                              <m:ctrlPr>
-                                <a:rPr lang="en-US" sz="1600" i="1" dirty="0">
-                                  <a:solidFill>
-                                    <a:schemeClr val="tx1"/>
-                                  </a:solidFill>
-                                  <a:latin typeface="Cambria Math" panose="02040503050406030204" pitchFamily="18" charset="0"/>
-                                </a:rPr>
-                              </m:ctrlPr>
-                            </m:fPr>
-                            <m:num>
-                              <m:r>
-                                <a:rPr lang="en-US" sz="1600" i="1" dirty="0">
-                                  <a:solidFill>
-                                    <a:schemeClr val="tx1"/>
-                                  </a:solidFill>
-                                  <a:latin typeface="Cambria Math" panose="02040503050406030204" pitchFamily="18" charset="0"/>
-                                </a:rPr>
-                                <m:t>𝜋</m:t>
-                              </m:r>
-                              <m:r>
-                                <a:rPr lang="en-US" sz="1600" i="1" dirty="0">
-                                  <a:solidFill>
-                                    <a:schemeClr val="tx1"/>
-                                  </a:solidFill>
-                                  <a:latin typeface="Cambria Math" panose="02040503050406030204" pitchFamily="18" charset="0"/>
-                                </a:rPr>
-                                <m:t>𝑠</m:t>
-                              </m:r>
-                            </m:num>
-                            <m:den>
-                              <m:r>
-                                <a:rPr lang="en-US" sz="1600" i="1" dirty="0">
-                                  <a:solidFill>
-                                    <a:schemeClr val="tx1"/>
-                                  </a:solidFill>
-                                  <a:latin typeface="Cambria Math" panose="02040503050406030204" pitchFamily="18" charset="0"/>
-                                </a:rPr>
-                                <m:t>𝐿</m:t>
-                              </m:r>
-                            </m:den>
-                          </m:f>
-                        </m:e>
-                      </m:func>
-                      <m:r>
-                        <a:rPr lang="en-US" sz="1600" i="0" dirty="0">
-                          <a:solidFill>
-                            <a:schemeClr val="tx1"/>
-                          </a:solidFill>
-                          <a:latin typeface="Cambria Math" panose="02040503050406030204" pitchFamily="18" charset="0"/>
-                        </a:rPr>
-                        <m:t>,  </m:t>
-                      </m:r>
-                      <m:r>
-                        <a:rPr lang="en-US" sz="1600" i="1" dirty="0">
-                          <a:solidFill>
-                            <a:schemeClr val="tx1"/>
-                          </a:solidFill>
-                          <a:latin typeface="Cambria Math" panose="02040503050406030204" pitchFamily="18" charset="0"/>
-                        </a:rPr>
-                        <m:t>𝐴</m:t>
-                      </m:r>
-                      <m:r>
-                        <a:rPr lang="en-US" sz="1600" i="0" dirty="0">
-                          <a:solidFill>
-                            <a:schemeClr val="tx1"/>
-                          </a:solidFill>
-                          <a:latin typeface="Cambria Math" panose="02040503050406030204" pitchFamily="18" charset="0"/>
-                        </a:rPr>
-                        <m:t>=2</m:t>
-                      </m:r>
-                      <m:rad>
-                        <m:radPr>
-                          <m:degHide m:val="on"/>
-                          <m:ctrlPr>
-                            <a:rPr lang="en-US" sz="1600" i="1" dirty="0">
-                              <a:solidFill>
-                                <a:schemeClr val="tx1"/>
-                              </a:solidFill>
-                              <a:latin typeface="Cambria Math" panose="02040503050406030204" pitchFamily="18" charset="0"/>
-                            </a:rPr>
-                          </m:ctrlPr>
-                        </m:radPr>
-                        <m:deg/>
-                        <m:e>
-                          <m:func>
-                            <m:funcPr>
-                              <m:ctrlPr>
-                                <a:rPr lang="en-US" sz="1600" i="0" dirty="0">
-                                  <a:solidFill>
-                                    <a:schemeClr val="tx1"/>
-                                  </a:solidFill>
-                                  <a:latin typeface="Cambria Math" panose="02040503050406030204" pitchFamily="18" charset="0"/>
-                                </a:rPr>
-                              </m:ctrlPr>
-                            </m:funcPr>
-                            <m:fName>
-                              <m:r>
-                                <m:rPr>
-                                  <m:sty m:val="p"/>
-                                </m:rPr>
-                                <a:rPr lang="en-US" sz="1600" i="0" dirty="0">
-                                  <a:solidFill>
-                                    <a:schemeClr val="tx1"/>
-                                  </a:solidFill>
-                                  <a:latin typeface="Cambria Math" panose="02040503050406030204" pitchFamily="18" charset="0"/>
-                                </a:rPr>
-                                <m:t>max</m:t>
-                              </m:r>
-                            </m:fName>
-                            <m:e>
-                              <m:d>
-                                <m:dPr>
-                                  <m:ctrlPr>
-                                    <a:rPr lang="en-US" sz="1600" i="0" dirty="0">
-                                      <a:solidFill>
-                                        <a:schemeClr val="tx1"/>
-                                      </a:solidFill>
-                                      <a:latin typeface="Cambria Math" panose="02040503050406030204" pitchFamily="18" charset="0"/>
-                                    </a:rPr>
-                                  </m:ctrlPr>
-                                </m:dPr>
-                                <m:e>
-                                  <m:r>
-                                    <a:rPr lang="en-US" sz="1600" i="0" dirty="0">
-                                      <a:solidFill>
-                                        <a:schemeClr val="tx1"/>
-                                      </a:solidFill>
-                                      <a:latin typeface="Cambria Math" panose="02040503050406030204" pitchFamily="18" charset="0"/>
-                                    </a:rPr>
-                                    <m:t>0, 1−</m:t>
-                                  </m:r>
-                                  <m:r>
-                                    <a:rPr lang="en-US" sz="1600" i="1" dirty="0">
-                                      <a:solidFill>
-                                        <a:schemeClr val="tx1"/>
-                                      </a:solidFill>
-                                      <a:latin typeface="Cambria Math" panose="02040503050406030204" pitchFamily="18" charset="0"/>
-                                    </a:rPr>
-                                    <m:t>𝑑</m:t>
-                                  </m:r>
-                                  <m:r>
-                                    <a:rPr lang="en-US" sz="1600" i="0" dirty="0">
-                                      <a:solidFill>
-                                        <a:schemeClr val="tx1"/>
-                                      </a:solidFill>
-                                      <a:latin typeface="Cambria Math" panose="02040503050406030204" pitchFamily="18" charset="0"/>
-                                    </a:rPr>
-                                    <m:t>/</m:t>
-                                  </m:r>
-                                  <m:r>
-                                    <a:rPr lang="en-US" sz="1600" i="1" dirty="0">
-                                      <a:solidFill>
-                                        <a:schemeClr val="tx1"/>
-                                      </a:solidFill>
-                                      <a:latin typeface="Cambria Math" panose="02040503050406030204" pitchFamily="18" charset="0"/>
-                                    </a:rPr>
-                                    <m:t>𝐿</m:t>
-                                  </m:r>
-                                </m:e>
-                              </m:d>
-                            </m:e>
-                          </m:func>
-                        </m:e>
-                      </m:rad>
-                    </m:oMath>
-                  </m:oMathPara>
-                </a14:m>
-                <a:endParaRPr lang="en-US" sz="1600" dirty="0"/>
-              </a:p>
-            </p:txBody>
-          </p:sp>
-        </mc:Choice>
-        <mc:Fallback xmlns="">
-          <p:sp>
-            <p:nvSpPr>
-              <p:cNvPr id="4" name="latex-cold"/>
-              <p:cNvSpPr txBox="1">
-                <a:spLocks noRot="1" noChangeAspect="1" noMove="1" noResize="1" noEditPoints="1" noAdjustHandles="1" noChangeArrowheads="1" noChangeShapeType="1" noTextEdit="1"/>
-              </p:cNvSpPr>
-              <p:nvPr/>
-            </p:nvSpPr>
-            <p:spPr>
-              <a:xfrm>
-                <a:off x="822960" y="1656984"/>
-                <a:ext cx="10607040" cy="435072"/>
-              </a:xfrm>
-              <a:prstGeom prst="rect">
-                <a:avLst/>
-              </a:prstGeom>
-              <a:blipFill>
-                <a:blip r:embed="rId3"/>
-                <a:stretch>
-                  <a:fillRect b="-14085"/>
-                </a:stretch>
-              </a:blipFill>
-              <a:ln/>
-            </p:spPr>
-            <p:txBody>
-              <a:bodyPr/>
-              <a:lstStyle/>
-              <a:p>
-                <a:r>
-                  <a:rPr lang="en-IN">
-                    <a:noFill/>
-                  </a:rPr>
-                  <a:t> </a:t>
-                </a:r>
-              </a:p>
-            </p:txBody>
-          </p:sp>
-        </mc:Fallback>
-      </mc:AlternateContent>
-      <p:pic>
-        <p:nvPicPr>
-          <p:cNvPr id="5" name="figure-135" descr="/tmp/claude-1000/-home-goraksh/bd4a8aa0-f932-4355-8328-b02b4cf010d1/scratchpad/deck/fig/coldstart.png"/>
-          <p:cNvPicPr>
-            <a:picLocks noChangeAspect="1"/>
-          </p:cNvPicPr>
-          <p:nvPr/>
-        </p:nvPicPr>
-        <p:blipFill>
-          <a:blip r:embed="rId4"/>
-          <a:stretch>
-            <a:fillRect/>
-          </a:stretch>
-        </p:blipFill>
-        <p:spPr>
-          <a:xfrm>
-            <a:off x="457200" y="2560320"/>
-            <a:ext cx="5394960" cy="3596640"/>
-          </a:xfrm>
-          <a:prstGeom prst="rect">
-            <a:avLst/>
-          </a:prstGeom>
-        </p:spPr>
-      </p:pic>
-      <p:sp>
-        <p:nvSpPr>
-          <p:cNvPr id="6" name="text-136"/>
-          <p:cNvSpPr txBox="1"/>
-          <p:nvPr/>
-        </p:nvSpPr>
-        <p:spPr>
-          <a:xfrm>
-            <a:off x="6217920" y="2606040"/>
-            <a:ext cx="5394960" cy="365760"/>
-          </a:xfrm>
-          <a:prstGeom prst="rect">
-            <a:avLst/>
-          </a:prstGeom>
-          <a:noFill/>
-          <a:ln/>
-        </p:spPr>
-        <p:txBody>
-          <a:bodyPr wrap="square" lIns="0" tIns="0" rIns="0" bIns="0" rtlCol="0" anchor="t"/>
-          <a:lstStyle/>
-          <a:p>
-            <a:pPr marL="0" indent="0">
-              <a:buNone/>
-            </a:pPr>
-            <a:r>
-              <a:rPr lang="en-US" sz="1600" b="1" dirty="0">
-                <a:solidFill>
-                  <a:schemeClr val="accent1"/>
-                </a:solidFill>
-              </a:rPr>
-              <a:t>Amplitude from the small-angle constraint</a:t>
-            </a:r>
-            <a:endParaRPr lang="en-US" sz="1600" dirty="0"/>
-          </a:p>
-        </p:txBody>
-      </p:sp>
-      <mc:AlternateContent xmlns:mc="http://schemas.openxmlformats.org/markup-compatibility/2006" xmlns:a14="http://schemas.microsoft.com/office/drawing/2010/main">
-        <mc:Choice Requires="a14">
-          <p:sp>
-            <p:nvSpPr>
-              <p:cNvPr id="7" name="latex-amp"/>
-              <p:cNvSpPr txBox="1"/>
-              <p:nvPr/>
-            </p:nvSpPr>
-            <p:spPr>
-              <a:xfrm>
-                <a:off x="6217920" y="3017520"/>
-                <a:ext cx="5425135" cy="662208"/>
-              </a:xfrm>
-              <a:prstGeom prst="rect">
-                <a:avLst/>
-              </a:prstGeom>
-              <a:noFill/>
-              <a:ln/>
-            </p:spPr>
-            <p:txBody>
-              <a:bodyPr wrap="square" lIns="0" tIns="0" rIns="0" bIns="0" rtlCol="0" anchor="ctr">
-                <a:noAutofit/>
-              </a:bodyPr>
-              <a:lstStyle/>
-              <a:p>
-                <a:pPr marL="0" indent="0">
-                  <a:buNone/>
-                </a:pPr>
-                <a14:m>
-                  <m:oMathPara xmlns:m="http://schemas.openxmlformats.org/officeDocument/2006/math">
-                    <m:oMath>
-                      <m:f>
-                        <m:fPr>
-                          <m:ctrlPr>
-                            <a:rPr lang="en-US" sz="1600" i="1" dirty="0">
-                              <a:solidFill>
-                                <a:schemeClr val="tx1"/>
-                              </a:solidFill>
-                              <a:latin typeface="Cambria Math" panose="02040503050406030204" pitchFamily="18" charset="0"/>
-                            </a:rPr>
-                          </m:ctrlPr>
-                        </m:fPr>
-                        <m:num>
-                          <m:r>
-                            <a:rPr lang="en-US" sz="1600" i="1" dirty="0">
-                              <a:solidFill>
-                                <a:schemeClr val="tx1"/>
-                              </a:solidFill>
-                              <a:latin typeface="Cambria Math" panose="02040503050406030204" pitchFamily="18" charset="0"/>
-                            </a:rPr>
-                            <m:t>𝑑</m:t>
-                          </m:r>
-                        </m:num>
-                        <m:den>
-                          <m:r>
-                            <a:rPr lang="en-US" sz="1600" i="1" dirty="0">
-                              <a:solidFill>
-                                <a:schemeClr val="tx1"/>
-                              </a:solidFill>
-                              <a:latin typeface="Cambria Math" panose="02040503050406030204" pitchFamily="18" charset="0"/>
-                            </a:rPr>
-                            <m:t>𝐿</m:t>
-                          </m:r>
-                        </m:den>
-                      </m:f>
-                      <m:r>
-                        <a:rPr lang="en-US" sz="1600" i="0" dirty="0">
-                          <a:solidFill>
-                            <a:schemeClr val="tx1"/>
-                          </a:solidFill>
-                          <a:latin typeface="Cambria Math" panose="02040503050406030204" pitchFamily="18" charset="0"/>
-                        </a:rPr>
-                        <m:t>≈</m:t>
-                      </m:r>
-                      <m:f>
-                        <m:fPr>
-                          <m:ctrlPr>
-                            <a:rPr lang="en-US" sz="1600" i="0" dirty="0">
-                              <a:solidFill>
-                                <a:schemeClr val="tx1"/>
-                              </a:solidFill>
-                              <a:latin typeface="Cambria Math" panose="02040503050406030204" pitchFamily="18" charset="0"/>
-                            </a:rPr>
-                          </m:ctrlPr>
-                        </m:fPr>
-                        <m:num>
-                          <m:r>
-                            <a:rPr lang="en-US" sz="1600" i="0" dirty="0">
-                              <a:solidFill>
-                                <a:schemeClr val="tx1"/>
-                              </a:solidFill>
-                              <a:latin typeface="Cambria Math" panose="02040503050406030204" pitchFamily="18" charset="0"/>
-                            </a:rPr>
-                            <m:t>1</m:t>
-                          </m:r>
-                        </m:num>
-                        <m:den>
-                          <m:r>
-                            <a:rPr lang="en-US" sz="1600" i="1" dirty="0">
-                              <a:solidFill>
-                                <a:schemeClr val="tx1"/>
-                              </a:solidFill>
-                              <a:latin typeface="Cambria Math" panose="02040503050406030204" pitchFamily="18" charset="0"/>
-                            </a:rPr>
-                            <m:t>𝐿</m:t>
-                          </m:r>
-                        </m:den>
-                      </m:f>
-                      <m:nary>
-                        <m:naryPr>
-                          <m:limLoc m:val="subSup"/>
-                          <m:ctrlPr>
-                            <a:rPr lang="en-US" sz="1600" i="0" dirty="0">
-                              <a:solidFill>
-                                <a:schemeClr val="tx1"/>
-                              </a:solidFill>
-                              <a:latin typeface="Cambria Math" panose="02040503050406030204" pitchFamily="18" charset="0"/>
-                            </a:rPr>
-                          </m:ctrlPr>
-                        </m:naryPr>
-                        <m:sub>
-                          <m:r>
-                            <a:rPr lang="en-US" sz="1600" i="0" dirty="0">
-                              <a:solidFill>
-                                <a:schemeClr val="tx1"/>
-                              </a:solidFill>
-                              <a:latin typeface="Cambria Math" panose="02040503050406030204" pitchFamily="18" charset="0"/>
-                            </a:rPr>
-                            <m:t>0</m:t>
-                          </m:r>
-                        </m:sub>
-                        <m:sup>
-                          <m:r>
-                            <a:rPr lang="en-US" sz="1600" i="1" dirty="0">
-                              <a:solidFill>
-                                <a:schemeClr val="tx1"/>
-                              </a:solidFill>
-                              <a:latin typeface="Cambria Math" panose="02040503050406030204" pitchFamily="18" charset="0"/>
-                            </a:rPr>
-                            <m:t>𝐿</m:t>
-                          </m:r>
-                        </m:sup>
-                        <m:e>
-                          <m:d>
-                            <m:dPr>
-                              <m:ctrlPr>
-                                <a:rPr lang="en-US" sz="1600" i="0" dirty="0">
-                                  <a:solidFill>
-                                    <a:schemeClr val="tx1"/>
-                                  </a:solidFill>
-                                  <a:latin typeface="Cambria Math" panose="02040503050406030204" pitchFamily="18" charset="0"/>
-                                </a:rPr>
-                              </m:ctrlPr>
-                            </m:dPr>
-                            <m:e>
-                              <m:r>
-                                <a:rPr lang="en-US" sz="1600" i="0" dirty="0">
-                                  <a:solidFill>
-                                    <a:schemeClr val="tx1"/>
-                                  </a:solidFill>
-                                  <a:latin typeface="Cambria Math" panose="02040503050406030204" pitchFamily="18" charset="0"/>
-                                </a:rPr>
-                                <m:t>1−</m:t>
-                              </m:r>
-                              <m:f>
-                                <m:fPr>
-                                  <m:ctrlPr>
-                                    <a:rPr lang="en-US" sz="1600" i="1" dirty="0">
-                                      <a:solidFill>
-                                        <a:schemeClr val="tx1"/>
-                                      </a:solidFill>
-                                      <a:latin typeface="Cambria Math" panose="02040503050406030204" pitchFamily="18" charset="0"/>
-                                    </a:rPr>
-                                  </m:ctrlPr>
-                                </m:fPr>
-                                <m:num>
-                                  <m:sSup>
-                                    <m:sSupPr>
-                                      <m:ctrlPr>
-                                        <a:rPr lang="en-US" sz="1600" i="1" dirty="0">
-                                          <a:solidFill>
-                                            <a:schemeClr val="tx1"/>
-                                          </a:solidFill>
-                                          <a:latin typeface="Cambria Math" panose="02040503050406030204" pitchFamily="18" charset="0"/>
-                                        </a:rPr>
-                                      </m:ctrlPr>
-                                    </m:sSupPr>
-                                    <m:e>
-                                      <m:r>
-                                        <a:rPr lang="en-US" sz="1600" i="1" dirty="0">
-                                          <a:solidFill>
-                                            <a:schemeClr val="tx1"/>
-                                          </a:solidFill>
-                                          <a:latin typeface="Cambria Math" panose="02040503050406030204" pitchFamily="18" charset="0"/>
-                                        </a:rPr>
-                                        <m:t>𝜃</m:t>
-                                      </m:r>
-                                    </m:e>
-                                    <m:sup>
-                                      <m:r>
-                                        <a:rPr lang="en-US" sz="1600" i="0" dirty="0">
-                                          <a:solidFill>
-                                            <a:schemeClr val="tx1"/>
-                                          </a:solidFill>
-                                          <a:latin typeface="Cambria Math" panose="02040503050406030204" pitchFamily="18" charset="0"/>
-                                        </a:rPr>
-                                        <m:t>2</m:t>
-                                      </m:r>
-                                    </m:sup>
-                                  </m:sSup>
-                                </m:num>
-                                <m:den>
-                                  <m:r>
-                                    <a:rPr lang="en-US" sz="1600" i="0" dirty="0">
-                                      <a:solidFill>
-                                        <a:schemeClr val="tx1"/>
-                                      </a:solidFill>
-                                      <a:latin typeface="Cambria Math" panose="02040503050406030204" pitchFamily="18" charset="0"/>
-                                    </a:rPr>
-                                    <m:t>2</m:t>
-                                  </m:r>
-                                </m:den>
-                              </m:f>
-                            </m:e>
-                          </m:d>
-                        </m:e>
-                      </m:nary>
-                      <m:r>
-                        <a:rPr lang="en-US" sz="1600" i="1" dirty="0">
-                          <a:solidFill>
-                            <a:schemeClr val="tx1"/>
-                          </a:solidFill>
-                          <a:latin typeface="Cambria Math" panose="02040503050406030204" pitchFamily="18" charset="0"/>
-                        </a:rPr>
-                        <m:t>𝑑𝑠</m:t>
-                      </m:r>
-                      <m:r>
-                        <a:rPr lang="en-US" sz="1600" i="0" dirty="0">
-                          <a:solidFill>
-                            <a:schemeClr val="tx1"/>
-                          </a:solidFill>
-                          <a:latin typeface="Cambria Math" panose="02040503050406030204" pitchFamily="18" charset="0"/>
-                        </a:rPr>
-                        <m:t> ⇒ </m:t>
-                      </m:r>
-                      <m:f>
-                        <m:fPr>
-                          <m:ctrlPr>
-                            <a:rPr lang="en-US" sz="1600" i="1" dirty="0">
-                              <a:solidFill>
-                                <a:schemeClr val="tx1"/>
-                              </a:solidFill>
-                              <a:latin typeface="Cambria Math" panose="02040503050406030204" pitchFamily="18" charset="0"/>
-                            </a:rPr>
-                          </m:ctrlPr>
-                        </m:fPr>
-                        <m:num>
-                          <m:r>
-                            <a:rPr lang="en-US" sz="1600" i="1" dirty="0">
-                              <a:solidFill>
-                                <a:schemeClr val="tx1"/>
-                              </a:solidFill>
-                              <a:latin typeface="Cambria Math" panose="02040503050406030204" pitchFamily="18" charset="0"/>
-                            </a:rPr>
-                            <m:t>𝑑</m:t>
-                          </m:r>
-                        </m:num>
-                        <m:den>
-                          <m:r>
-                            <a:rPr lang="en-US" sz="1600" i="1" dirty="0">
-                              <a:solidFill>
-                                <a:schemeClr val="tx1"/>
-                              </a:solidFill>
-                              <a:latin typeface="Cambria Math" panose="02040503050406030204" pitchFamily="18" charset="0"/>
-                            </a:rPr>
-                            <m:t>𝐿</m:t>
-                          </m:r>
-                        </m:den>
-                      </m:f>
-                      <m:r>
-                        <a:rPr lang="en-US" sz="1600" i="0" dirty="0">
-                          <a:solidFill>
-                            <a:schemeClr val="tx1"/>
-                          </a:solidFill>
-                          <a:latin typeface="Cambria Math" panose="02040503050406030204" pitchFamily="18" charset="0"/>
-                        </a:rPr>
-                        <m:t>≈1−</m:t>
-                      </m:r>
-                      <m:f>
-                        <m:fPr>
-                          <m:ctrlPr>
-                            <a:rPr lang="en-US" sz="1600" i="1" dirty="0">
-                              <a:solidFill>
-                                <a:schemeClr val="tx1"/>
-                              </a:solidFill>
-                              <a:latin typeface="Cambria Math" panose="02040503050406030204" pitchFamily="18" charset="0"/>
-                            </a:rPr>
-                          </m:ctrlPr>
-                        </m:fPr>
-                        <m:num>
-                          <m:sSup>
-                            <m:sSupPr>
-                              <m:ctrlPr>
-                                <a:rPr lang="en-US" sz="1600" i="1" dirty="0">
-                                  <a:solidFill>
-                                    <a:schemeClr val="tx1"/>
-                                  </a:solidFill>
-                                  <a:latin typeface="Cambria Math" panose="02040503050406030204" pitchFamily="18" charset="0"/>
-                                </a:rPr>
-                              </m:ctrlPr>
-                            </m:sSupPr>
-                            <m:e>
-                              <m:r>
-                                <a:rPr lang="en-US" sz="1600" i="1" dirty="0">
-                                  <a:solidFill>
-                                    <a:schemeClr val="tx1"/>
-                                  </a:solidFill>
-                                  <a:latin typeface="Cambria Math" panose="02040503050406030204" pitchFamily="18" charset="0"/>
-                                </a:rPr>
-                                <m:t>𝐴</m:t>
-                              </m:r>
-                            </m:e>
-                            <m:sup>
-                              <m:r>
-                                <a:rPr lang="en-US" sz="1600" i="0" dirty="0">
-                                  <a:solidFill>
-                                    <a:schemeClr val="tx1"/>
-                                  </a:solidFill>
-                                  <a:latin typeface="Cambria Math" panose="02040503050406030204" pitchFamily="18" charset="0"/>
-                                </a:rPr>
-                                <m:t>2</m:t>
-                              </m:r>
-                            </m:sup>
-                          </m:sSup>
-                        </m:num>
-                        <m:den>
-                          <m:r>
-                            <a:rPr lang="en-US" sz="1600" i="0" dirty="0">
-                              <a:solidFill>
-                                <a:schemeClr val="tx1"/>
-                              </a:solidFill>
-                              <a:latin typeface="Cambria Math" panose="02040503050406030204" pitchFamily="18" charset="0"/>
-                            </a:rPr>
-                            <m:t>4</m:t>
                           </m:r>
                         </m:den>
                       </m:f>
@@ -8349,7 +8424,7 @@
                   <a:schemeClr val="tx1"/>
                 </a:solidFill>
               </a:rPr>
-              <a:t>sin(πs/L) is the n = 1 buckling shape: one hump, zero at both clamps, so the BCs hold exactly</a:t>
+              <a:t>Exact at φ₁ = φ₂ = 0 for any d, with ∫ sin θ ds = 0: Newton converges in 2 iterations</a:t>
             </a:r>
             <a:endParaRPr lang="en-US" sz="1400" dirty="0"/>
           </a:p>
@@ -8448,7 +8523,7 @@
                   <a:schemeClr val="tx1"/>
                 </a:solidFill>
               </a:rPr>
-              <a:t>The bow grows with compression and vanishes as d → L</a:t>
+              <a:t>Steps ≤ 0.25 rad, ≤ 15 Newton iterations each; a failed step halves, giving up below 0.02 rad (a fold)</a:t>
             </a:r>
             <a:endParaRPr lang="en-US" sz="1400" dirty="0"/>
           </a:p>
@@ -8547,7 +8622,7 @@
                   <a:schemeClr val="tx1"/>
                 </a:solidFill>
               </a:rPr>
-              <a:t>A plain ramp is a circular arc, far from equilibrium once compressed; Newton then finds higher modes or diverges</a:t>
+              <a:t>Both hump signs are continued and the lower energy kept: 296 / 300 random points converge, vs 285 for sin(πs)</a:t>
             </a:r>
             <a:endParaRPr lang="en-US" sz="1400" dirty="0"/>
           </a:p>
@@ -14942,7 +15017,7 @@
                             <a:schemeClr val="tx1"/>
                           </a:solidFill>
                         </a:rPr>
-                        <a:t>Sorted by distance from the cold-start node</a:t>
+                        <a:t>By grid distance from the cold-start node</a:t>
                       </a:r>
                       <a:endParaRPr lang="en-US" sz="1400" dirty="0"/>
                     </a:p>
@@ -15123,7 +15198,7 @@
                             <a:schemeClr val="tx1"/>
                           </a:solidFill>
                         </a:rPr>
-                        <a:t>Previously solved node</a:t>
+                        <a:t>Each solved grid neighbour, nearest first</a:t>
                       </a:r>
                       <a:endParaRPr lang="en-US" sz="1400" dirty="0"/>
                     </a:p>
@@ -15485,7 +15560,7 @@
                             <a:schemeClr val="tx1"/>
                           </a:solidFill>
                         </a:rPr>
-                        <a:t>Cold restart from first-mode guess</a:t>
+                        <a:t>Try the next neighbour</a:t>
                       </a:r>
                       <a:endParaRPr lang="en-US" sz="1400" dirty="0"/>
                     </a:p>
@@ -15666,7 +15741,7 @@
                             <a:schemeClr val="tx1"/>
                           </a:solidFill>
                         </a:rPr>
-                        <a:t>Any node that fails</a:t>
+                        <a:t>At φ = 0, smallest d; then only if all fail</a:t>
                       </a:r>
                       <a:endParaRPr lang="en-US" sz="1400" dirty="0"/>
                     </a:p>
@@ -16536,7 +16611,7 @@
                   <a:schemeClr val="tx1"/>
                 </a:solidFill>
               </a:rPr>
-              <a:t>Visit order (v4)</a:t>
+              <a:t>Taut top layer, d = 0.9999 (v4)</a:t>
             </a:r>
             <a:endParaRPr lang="en-US" sz="1700" dirty="0"/>
           </a:p>
@@ -16572,7 +16647,7 @@
                   <a:schemeClr val="tx1"/>
                 </a:solidFill>
               </a:rPr>
-              <a:t>Nodes sorted by distance from the start sit on shells, so consecutive nodes can be far apart. The previous node is then a poor warm start, and the MAC gate fires more than it needs to.</a:t>
+              <a:t>Every failed node in a 90 s run of the production grid had d = 0.9999. With 10⁻⁴ of slack the clamps force a boundary layer about 10⁻³ thick, a tenth of an element. Cap d near 0.995 or refine the beam.</a:t>
             </a:r>
             <a:endParaRPr lang="en-US" sz="1500" dirty="0"/>
           </a:p>
@@ -22397,7 +22472,7 @@
                   <a:schemeClr val="accent5"/>
                 </a:solidFill>
               </a:rPr>
-              <a:t>from v3 sol4 and v4 run timestamps</a:t>
+              <a:t>v3 sol4 and v4 timestamps, before the one-thread fix (v4 now ≈ 3 ms)</a:t>
             </a:r>
             <a:endParaRPr lang="en-US" sz="1150" dirty="0"/>
           </a:p>
@@ -28703,7 +28778,7 @@
                   <a:schemeClr val="bg2"/>
                 </a:solidFill>
               </a:rPr>
-              <a:t>v4 gates a cold restart with it. v3 drives step halving with it and accepts a jump only once it survives 32 sub-steps.</a:t>
+              <a:t>v4 gates each neighbour's warm start with it and cold-starts only when all fail. v3 drives step halving with it and accepts a jump only once it survives 32 sub-steps.</a:t>
             </a:r>
             <a:endParaRPr lang="en-US" sz="1600" dirty="0"/>
           </a:p>
@@ -28742,6 +28817,1035 @@
               <a:t>Next: fix the mirrored-moment sign · mesh-convergence check near d → 1 · branch-aware production run for the controller dataset</a:t>
             </a:r>
             <a:endParaRPr lang="en-US" sz="1600" dirty="0"/>
+          </a:p>
+        </p:txBody>
+      </p:sp>
+    </p:spTree>
+  </p:cSld>
+  <p:clrMapOvr>
+    <a:masterClrMapping/>
+  </p:clrMapOvr>
+</p:sld>
+</file>
+
+<file path=ppt/slides/slide33.xml><?xml version="1.0" encoding="utf-8"?>
+<p:sld xmlns:a="http://schemas.openxmlformats.org/drawingml/2006/main" xmlns:r="http://schemas.openxmlformats.org/officeDocument/2006/relationships" xmlns:p="http://schemas.openxmlformats.org/presentationml/2006/main">
+  <p:cSld name="v4 update Slide 19">
+    <p:spTree>
+      <p:nvGrpSpPr>
+        <p:cNvPr id="1" name=""/>
+        <p:cNvGrpSpPr/>
+        <p:nvPr/>
+      </p:nvGrpSpPr>
+      <p:grpSpPr>
+        <a:xfrm>
+          <a:off x="0" y="0"/>
+          <a:ext cx="0" cy="0"/>
+          <a:chOff x="0" y="0"/>
+          <a:chExt cx="0" cy="0"/>
+        </a:xfrm>
+      </p:grpSpPr>
+      <p:sp>
+        <p:nvSpPr>
+          <p:cNvPr id="2" name="Text 0"/>
+          <p:cNvSpPr>
+            <a:spLocks noGrp="1"/>
+          </p:cNvSpPr>
+          <p:nvPr>
+            <p:ph type="title" idx="100" hasCustomPrompt="1"/>
+          </p:nvPr>
+        </p:nvSpPr>
+        <p:spPr>
+          <a:xfrm>
+            <a:off x="548640" y="320040"/>
+            <a:ext cx="11064240" cy="868680"/>
+          </a:xfrm>
+          <a:prstGeom prst="rect">
+            <a:avLst/>
+          </a:prstGeom>
+          <a:noFill/>
+          <a:ln/>
+        </p:spPr>
+        <p:txBody>
+          <a:bodyPr wrap="square" lIns="0" tIns="0" rIns="0" bIns="0" rtlCol="0" anchor="ctr"/>
+          <a:lstStyle/>
+          <a:p>
+            <a:pPr marL="0" indent="0" algn="l">
+              <a:buNone/>
+            </a:pPr>
+            <a:r>
+              <a:rPr lang="en-US" sz="3000" b="1" dirty="0">
+                <a:solidFill>
+                  <a:schemeClr val="tx1"/>
+                </a:solidFill>
+              </a:rPr>
+              <a:t>CURRENTv4 update: faster solves, fewer failures</a:t>
+            </a:r>
+            <a:endParaRPr lang="en-US" sz="3000" dirty="0"/>
+          </a:p>
+        </p:txBody>
+      </p:sp>
+      <p:sp>
+        <p:nvSpPr>
+          <p:cNvPr id="274" name="card-274"/>
+          <p:cNvSpPr/>
+          <p:nvPr/>
+        </p:nvSpPr>
+        <p:spPr>
+          <a:xfrm>
+            <a:off x="548640" y="1371600"/>
+            <a:ext cx="2560320" cy="1783080"/>
+          </a:xfrm>
+          <a:prstGeom prst="roundRect">
+            <a:avLst>
+              <a:gd name="adj" fmla="val 6000"/>
+            </a:avLst>
+          </a:prstGeom>
+          <a:solidFill>
+            <a:schemeClr val="bg2"/>
+          </a:solidFill>
+          <a:ln>
+            <a:noFill/>
+          </a:ln>
+        </p:spPr>
+        <p:txBody>
+          <a:bodyPr/>
+          <a:lstStyle/>
+          <a:p>
+            <a:endParaRPr lang="en-IN"/>
+          </a:p>
+        </p:txBody>
+      </p:sp>
+      <p:sp>
+        <p:nvSpPr>
+          <p:cNvPr id="275" name="tile-big-275"/>
+          <p:cNvSpPr txBox="1"/>
+          <p:nvPr/>
+        </p:nvSpPr>
+        <p:spPr>
+          <a:xfrm>
+            <a:off x="749808" y="1481328"/>
+            <a:ext cx="2194560" cy="685800"/>
+          </a:xfrm>
+          <a:prstGeom prst="rect">
+            <a:avLst/>
+          </a:prstGeom>
+          <a:noFill/>
+          <a:ln/>
+        </p:spPr>
+        <p:txBody>
+          <a:bodyPr wrap="square" lIns="0" tIns="0" rIns="0" bIns="0" rtlCol="0" anchor="ctr"/>
+          <a:lstStyle/>
+          <a:p>
+            <a:pPr marL="0" indent="0">
+              <a:spcAft>
+                <a:spcPts val="0"/>
+              </a:spcAft>
+              <a:buNone/>
+            </a:pPr>
+            <a:r>
+              <a:rPr lang="en-US" sz="3000" b="1" dirty="0">
+                <a:solidFill>
+                  <a:schemeClr val="accent1"/>
+                </a:solidFill>
+              </a:rPr>
+              <a:t>40×</a:t>
+            </a:r>
+            <a:endParaRPr lang="en-US" sz="3000" dirty="0"/>
+          </a:p>
+        </p:txBody>
+      </p:sp>
+      <p:sp>
+        <p:nvSpPr>
+          <p:cNvPr id="276" name="tile-label-276"/>
+          <p:cNvSpPr txBox="1"/>
+          <p:nvPr/>
+        </p:nvSpPr>
+        <p:spPr>
+          <a:xfrm>
+            <a:off x="749808" y="2212848"/>
+            <a:ext cx="2194560" cy="320040"/>
+          </a:xfrm>
+          <a:prstGeom prst="rect">
+            <a:avLst/>
+          </a:prstGeom>
+          <a:noFill/>
+          <a:ln/>
+        </p:spPr>
+        <p:txBody>
+          <a:bodyPr wrap="square" lIns="0" tIns="0" rIns="0" bIns="0" rtlCol="0" anchor="t"/>
+          <a:lstStyle/>
+          <a:p>
+            <a:pPr marL="0" indent="0">
+              <a:spcAft>
+                <a:spcPts val="0"/>
+              </a:spcAft>
+              <a:buNone/>
+            </a:pPr>
+            <a:r>
+              <a:rPr lang="en-US" sz="1400" b="1" dirty="0">
+                <a:solidFill>
+                  <a:schemeClr val="tx1"/>
+                </a:solidFill>
+              </a:rPr>
+              <a:t>faster per solve</a:t>
+            </a:r>
+            <a:endParaRPr lang="en-US" sz="1400" dirty="0"/>
+          </a:p>
+        </p:txBody>
+      </p:sp>
+      <p:sp>
+        <p:nvSpPr>
+          <p:cNvPr id="277" name="tile-sub-277"/>
+          <p:cNvSpPr txBox="1"/>
+          <p:nvPr/>
+        </p:nvSpPr>
+        <p:spPr>
+          <a:xfrm>
+            <a:off x="749808" y="2560320"/>
+            <a:ext cx="2194560" cy="502920"/>
+          </a:xfrm>
+          <a:prstGeom prst="rect">
+            <a:avLst/>
+          </a:prstGeom>
+          <a:noFill/>
+          <a:ln/>
+        </p:spPr>
+        <p:txBody>
+          <a:bodyPr wrap="square" lIns="0" tIns="0" rIns="0" bIns="0" rtlCol="0" anchor="t"/>
+          <a:lstStyle/>
+          <a:p>
+            <a:pPr marL="0" indent="0">
+              <a:spcAft>
+                <a:spcPts val="0"/>
+              </a:spcAft>
+              <a:buNone/>
+            </a:pPr>
+            <a:r>
+              <a:rPr lang="en-US" sz="1150" dirty="0">
+                <a:solidFill>
+                  <a:schemeClr val="accent5"/>
+                </a:solidFill>
+              </a:rPr>
+              <a:t>single-threaded: 62 → 1.6 ms</a:t>
+            </a:r>
+            <a:endParaRPr lang="en-US" sz="1150" dirty="0"/>
+          </a:p>
+        </p:txBody>
+      </p:sp>
+      <p:sp>
+        <p:nvSpPr>
+          <p:cNvPr id="278" name="card-278"/>
+          <p:cNvSpPr/>
+          <p:nvPr/>
+        </p:nvSpPr>
+        <p:spPr>
+          <a:xfrm>
+            <a:off x="3383280" y="1371600"/>
+            <a:ext cx="2560320" cy="1783080"/>
+          </a:xfrm>
+          <a:prstGeom prst="roundRect">
+            <a:avLst>
+              <a:gd name="adj" fmla="val 6000"/>
+            </a:avLst>
+          </a:prstGeom>
+          <a:solidFill>
+            <a:schemeClr val="bg2"/>
+          </a:solidFill>
+          <a:ln>
+            <a:noFill/>
+          </a:ln>
+        </p:spPr>
+        <p:txBody>
+          <a:bodyPr/>
+          <a:lstStyle/>
+          <a:p>
+            <a:endParaRPr lang="en-IN"/>
+          </a:p>
+        </p:txBody>
+      </p:sp>
+      <p:sp>
+        <p:nvSpPr>
+          <p:cNvPr id="279" name="tile-big-279"/>
+          <p:cNvSpPr txBox="1"/>
+          <p:nvPr/>
+        </p:nvSpPr>
+        <p:spPr>
+          <a:xfrm>
+            <a:off x="3584448" y="1481328"/>
+            <a:ext cx="2194560" cy="685800"/>
+          </a:xfrm>
+          <a:prstGeom prst="rect">
+            <a:avLst/>
+          </a:prstGeom>
+          <a:noFill/>
+          <a:ln/>
+        </p:spPr>
+        <p:txBody>
+          <a:bodyPr wrap="square" lIns="0" tIns="0" rIns="0" bIns="0" rtlCol="0" anchor="ctr"/>
+          <a:lstStyle/>
+          <a:p>
+            <a:pPr marL="0" indent="0">
+              <a:spcAft>
+                <a:spcPts val="0"/>
+              </a:spcAft>
+              <a:buNone/>
+            </a:pPr>
+            <a:r>
+              <a:rPr lang="en-US" sz="3000" b="1" dirty="0">
+                <a:solidFill>
+                  <a:schemeClr val="accent1"/>
+                </a:solidFill>
+              </a:rPr>
+              <a:t>100 %</a:t>
+            </a:r>
+            <a:endParaRPr lang="en-US" sz="3000" dirty="0"/>
+          </a:p>
+        </p:txBody>
+      </p:sp>
+      <p:sp>
+        <p:nvSpPr>
+          <p:cNvPr id="280" name="tile-label-280"/>
+          <p:cNvSpPr txBox="1"/>
+          <p:nvPr/>
+        </p:nvSpPr>
+        <p:spPr>
+          <a:xfrm>
+            <a:off x="3584448" y="2212848"/>
+            <a:ext cx="2194560" cy="320040"/>
+          </a:xfrm>
+          <a:prstGeom prst="rect">
+            <a:avLst/>
+          </a:prstGeom>
+          <a:noFill/>
+          <a:ln/>
+        </p:spPr>
+        <p:txBody>
+          <a:bodyPr wrap="square" lIns="0" tIns="0" rIns="0" bIns="0" rtlCol="0" anchor="t"/>
+          <a:lstStyle/>
+          <a:p>
+            <a:pPr marL="0" indent="0">
+              <a:spcAft>
+                <a:spcPts val="0"/>
+              </a:spcAft>
+              <a:buNone/>
+            </a:pPr>
+            <a:r>
+              <a:rPr lang="en-US" sz="1400" b="1" dirty="0">
+                <a:solidFill>
+                  <a:schemeClr val="tx1"/>
+                </a:solidFill>
+              </a:rPr>
+              <a:t>of the test grid solved</a:t>
+            </a:r>
+            <a:endParaRPr lang="en-US" sz="1400" dirty="0"/>
+          </a:p>
+        </p:txBody>
+      </p:sp>
+      <p:sp>
+        <p:nvSpPr>
+          <p:cNvPr id="281" name="tile-sub-281"/>
+          <p:cNvSpPr txBox="1"/>
+          <p:nvPr/>
+        </p:nvSpPr>
+        <p:spPr>
+          <a:xfrm>
+            <a:off x="3584448" y="2560320"/>
+            <a:ext cx="2194560" cy="502920"/>
+          </a:xfrm>
+          <a:prstGeom prst="rect">
+            <a:avLst/>
+          </a:prstGeom>
+          <a:noFill/>
+          <a:ln/>
+        </p:spPr>
+        <p:txBody>
+          <a:bodyPr wrap="square" lIns="0" tIns="0" rIns="0" bIns="0" rtlCol="0" anchor="t"/>
+          <a:lstStyle/>
+          <a:p>
+            <a:pPr marL="0" indent="0">
+              <a:spcAft>
+                <a:spcPts val="0"/>
+              </a:spcAft>
+              <a:buNone/>
+            </a:pPr>
+            <a:r>
+              <a:rPr lang="en-US" sz="1150" dirty="0">
+                <a:solidFill>
+                  <a:schemeClr val="accent5"/>
+                </a:solidFill>
+              </a:rPr>
+              <a:t>was 98.2 % (1,299 of 1,323 points)</a:t>
+            </a:r>
+            <a:endParaRPr lang="en-US" sz="1150" dirty="0"/>
+          </a:p>
+        </p:txBody>
+      </p:sp>
+      <p:sp>
+        <p:nvSpPr>
+          <p:cNvPr id="282" name="card-282"/>
+          <p:cNvSpPr/>
+          <p:nvPr/>
+        </p:nvSpPr>
+        <p:spPr>
+          <a:xfrm>
+            <a:off x="6217920" y="1371600"/>
+            <a:ext cx="2560320" cy="1783080"/>
+          </a:xfrm>
+          <a:prstGeom prst="roundRect">
+            <a:avLst>
+              <a:gd name="adj" fmla="val 6000"/>
+            </a:avLst>
+          </a:prstGeom>
+          <a:solidFill>
+            <a:schemeClr val="bg2"/>
+          </a:solidFill>
+          <a:ln>
+            <a:noFill/>
+          </a:ln>
+        </p:spPr>
+        <p:txBody>
+          <a:bodyPr/>
+          <a:lstStyle/>
+          <a:p>
+            <a:endParaRPr lang="en-IN"/>
+          </a:p>
+        </p:txBody>
+      </p:sp>
+      <p:sp>
+        <p:nvSpPr>
+          <p:cNvPr id="283" name="tile-big-283"/>
+          <p:cNvSpPr txBox="1"/>
+          <p:nvPr/>
+        </p:nvSpPr>
+        <p:spPr>
+          <a:xfrm>
+            <a:off x="6419088" y="1481328"/>
+            <a:ext cx="2194560" cy="685800"/>
+          </a:xfrm>
+          <a:prstGeom prst="rect">
+            <a:avLst/>
+          </a:prstGeom>
+          <a:noFill/>
+          <a:ln/>
+        </p:spPr>
+        <p:txBody>
+          <a:bodyPr wrap="square" lIns="0" tIns="0" rIns="0" bIns="0" rtlCol="0" anchor="ctr"/>
+          <a:lstStyle/>
+          <a:p>
+            <a:pPr marL="0" indent="0">
+              <a:spcAft>
+                <a:spcPts val="0"/>
+              </a:spcAft>
+              <a:buNone/>
+            </a:pPr>
+            <a:r>
+              <a:rPr lang="en-US" sz="3000" b="1" dirty="0">
+                <a:solidFill>
+                  <a:schemeClr val="accent1"/>
+                </a:solidFill>
+              </a:rPr>
+              <a:t>296 / 300</a:t>
+            </a:r>
+            <a:endParaRPr lang="en-US" sz="3000" dirty="0"/>
+          </a:p>
+        </p:txBody>
+      </p:sp>
+      <p:sp>
+        <p:nvSpPr>
+          <p:cNvPr id="284" name="tile-label-284"/>
+          <p:cNvSpPr txBox="1"/>
+          <p:nvPr/>
+        </p:nvSpPr>
+        <p:spPr>
+          <a:xfrm>
+            <a:off x="6419088" y="2212848"/>
+            <a:ext cx="2194560" cy="320040"/>
+          </a:xfrm>
+          <a:prstGeom prst="rect">
+            <a:avLst/>
+          </a:prstGeom>
+          <a:noFill/>
+          <a:ln/>
+        </p:spPr>
+        <p:txBody>
+          <a:bodyPr wrap="square" lIns="0" tIns="0" rIns="0" bIns="0" rtlCol="0" anchor="t"/>
+          <a:lstStyle/>
+          <a:p>
+            <a:pPr marL="0" indent="0">
+              <a:spcAft>
+                <a:spcPts val="0"/>
+              </a:spcAft>
+              <a:buNone/>
+            </a:pPr>
+            <a:r>
+              <a:rPr lang="en-US" sz="1400" b="1" dirty="0">
+                <a:solidFill>
+                  <a:schemeClr val="tx1"/>
+                </a:solidFill>
+              </a:rPr>
+              <a:t>cold starts converge</a:t>
+            </a:r>
+            <a:endParaRPr lang="en-US" sz="1400" dirty="0"/>
+          </a:p>
+        </p:txBody>
+      </p:sp>
+      <p:sp>
+        <p:nvSpPr>
+          <p:cNvPr id="285" name="tile-sub-285"/>
+          <p:cNvSpPr txBox="1"/>
+          <p:nvPr/>
+        </p:nvSpPr>
+        <p:spPr>
+          <a:xfrm>
+            <a:off x="6419088" y="2560320"/>
+            <a:ext cx="2194560" cy="502920"/>
+          </a:xfrm>
+          <a:prstGeom prst="rect">
+            <a:avLst/>
+          </a:prstGeom>
+          <a:noFill/>
+          <a:ln/>
+        </p:spPr>
+        <p:txBody>
+          <a:bodyPr wrap="square" lIns="0" tIns="0" rIns="0" bIns="0" rtlCol="0" anchor="t"/>
+          <a:lstStyle/>
+          <a:p>
+            <a:pPr marL="0" indent="0">
+              <a:spcAft>
+                <a:spcPts val="0"/>
+              </a:spcAft>
+              <a:buNone/>
+            </a:pPr>
+            <a:r>
+              <a:rPr lang="en-US" sz="1150" dirty="0">
+                <a:solidFill>
+                  <a:schemeClr val="accent5"/>
+                </a:solidFill>
+              </a:rPr>
+              <a:t>old sin(πs) guess: 285 / 300</a:t>
+            </a:r>
+            <a:endParaRPr lang="en-US" sz="1150" dirty="0"/>
+          </a:p>
+        </p:txBody>
+      </p:sp>
+      <p:sp>
+        <p:nvSpPr>
+          <p:cNvPr id="286" name="card-286"/>
+          <p:cNvSpPr/>
+          <p:nvPr/>
+        </p:nvSpPr>
+        <p:spPr>
+          <a:xfrm>
+            <a:off x="9052560" y="1371600"/>
+            <a:ext cx="2560320" cy="1783080"/>
+          </a:xfrm>
+          <a:prstGeom prst="roundRect">
+            <a:avLst>
+              <a:gd name="adj" fmla="val 6000"/>
+            </a:avLst>
+          </a:prstGeom>
+          <a:solidFill>
+            <a:schemeClr val="bg2"/>
+          </a:solidFill>
+          <a:ln>
+            <a:noFill/>
+          </a:ln>
+        </p:spPr>
+        <p:txBody>
+          <a:bodyPr/>
+          <a:lstStyle/>
+          <a:p>
+            <a:endParaRPr lang="en-IN"/>
+          </a:p>
+        </p:txBody>
+      </p:sp>
+      <p:sp>
+        <p:nvSpPr>
+          <p:cNvPr id="287" name="tile-big-287"/>
+          <p:cNvSpPr txBox="1"/>
+          <p:nvPr/>
+        </p:nvSpPr>
+        <p:spPr>
+          <a:xfrm>
+            <a:off x="9253728" y="1481328"/>
+            <a:ext cx="2194560" cy="685800"/>
+          </a:xfrm>
+          <a:prstGeom prst="rect">
+            <a:avLst/>
+          </a:prstGeom>
+          <a:noFill/>
+          <a:ln/>
+        </p:spPr>
+        <p:txBody>
+          <a:bodyPr wrap="square" lIns="0" tIns="0" rIns="0" bIns="0" rtlCol="0" anchor="ctr"/>
+          <a:lstStyle/>
+          <a:p>
+            <a:pPr marL="0" indent="0">
+              <a:spcAft>
+                <a:spcPts val="0"/>
+              </a:spcAft>
+              <a:buNone/>
+            </a:pPr>
+            <a:r>
+              <a:rPr lang="en-US" sz="3000" b="1" dirty="0">
+                <a:solidFill>
+                  <a:schemeClr val="accent1"/>
+                </a:solidFill>
+              </a:rPr>
+              <a:t>78×</a:t>
+            </a:r>
+            <a:endParaRPr lang="en-US" sz="3000" dirty="0"/>
+          </a:p>
+        </p:txBody>
+      </p:sp>
+      <p:sp>
+        <p:nvSpPr>
+          <p:cNvPr id="288" name="tile-label-288"/>
+          <p:cNvSpPr txBox="1"/>
+          <p:nvPr/>
+        </p:nvSpPr>
+        <p:spPr>
+          <a:xfrm>
+            <a:off x="9253728" y="2212848"/>
+            <a:ext cx="2194560" cy="320040"/>
+          </a:xfrm>
+          <a:prstGeom prst="rect">
+            <a:avLst/>
+          </a:prstGeom>
+          <a:noFill/>
+          <a:ln/>
+        </p:spPr>
+        <p:txBody>
+          <a:bodyPr wrap="square" lIns="0" tIns="0" rIns="0" bIns="0" rtlCol="0" anchor="t"/>
+          <a:lstStyle/>
+          <a:p>
+            <a:pPr marL="0" indent="0">
+              <a:spcAft>
+                <a:spcPts val="0"/>
+              </a:spcAft>
+              <a:buNone/>
+            </a:pPr>
+            <a:r>
+              <a:rPr lang="en-US" sz="1400" b="1" dirty="0">
+                <a:solidFill>
+                  <a:schemeClr val="tx1"/>
+                </a:solidFill>
+              </a:rPr>
+              <a:t>faster test run</a:t>
+            </a:r>
+            <a:endParaRPr lang="en-US" sz="1400" dirty="0"/>
+          </a:p>
+        </p:txBody>
+      </p:sp>
+      <p:sp>
+        <p:nvSpPr>
+          <p:cNvPr id="289" name="tile-sub-289"/>
+          <p:cNvSpPr txBox="1"/>
+          <p:nvPr/>
+        </p:nvSpPr>
+        <p:spPr>
+          <a:xfrm>
+            <a:off x="9253728" y="2560320"/>
+            <a:ext cx="2194560" cy="502920"/>
+          </a:xfrm>
+          <a:prstGeom prst="rect">
+            <a:avLst/>
+          </a:prstGeom>
+          <a:noFill/>
+          <a:ln/>
+        </p:spPr>
+        <p:txBody>
+          <a:bodyPr wrap="square" lIns="0" tIns="0" rIns="0" bIns="0" rtlCol="0" anchor="t"/>
+          <a:lstStyle/>
+          <a:p>
+            <a:pPr marL="0" indent="0">
+              <a:spcAft>
+                <a:spcPts val="0"/>
+              </a:spcAft>
+              <a:buNone/>
+            </a:pPr>
+            <a:r>
+              <a:rPr lang="en-US" sz="1150" dirty="0">
+                <a:solidFill>
+                  <a:schemeClr val="accent5"/>
+                </a:solidFill>
+              </a:rPr>
+              <a:t>8 min 17 s → 6.4 s on 1,323 points</a:t>
+            </a:r>
+            <a:endParaRPr lang="en-US" sz="1150" dirty="0"/>
+          </a:p>
+        </p:txBody>
+      </p:sp>
+      <p:sp>
+        <p:nvSpPr>
+          <p:cNvPr id="290" name="card-290"/>
+          <p:cNvSpPr/>
+          <p:nvPr/>
+        </p:nvSpPr>
+        <p:spPr>
+          <a:xfrm>
+            <a:off x="548640" y="3429000"/>
+            <a:ext cx="3502152" cy="1828800"/>
+          </a:xfrm>
+          <a:prstGeom prst="roundRect">
+            <a:avLst>
+              <a:gd name="adj" fmla="val 6000"/>
+            </a:avLst>
+          </a:prstGeom>
+          <a:solidFill>
+            <a:schemeClr val="bg2"/>
+          </a:solidFill>
+          <a:ln>
+            <a:noFill/>
+          </a:ln>
+        </p:spPr>
+        <p:txBody>
+          <a:bodyPr/>
+          <a:lstStyle/>
+          <a:p>
+            <a:endParaRPr lang="en-IN"/>
+          </a:p>
+        </p:txBody>
+      </p:sp>
+      <p:sp>
+        <p:nvSpPr>
+          <p:cNvPr id="291" name="card-head-291"/>
+          <p:cNvSpPr txBox="1"/>
+          <p:nvPr/>
+        </p:nvSpPr>
+        <p:spPr>
+          <a:xfrm>
+            <a:off x="749808" y="3593592"/>
+            <a:ext cx="3099816" cy="365760"/>
+          </a:xfrm>
+          <a:prstGeom prst="rect">
+            <a:avLst/>
+          </a:prstGeom>
+          <a:noFill/>
+          <a:ln/>
+        </p:spPr>
+        <p:txBody>
+          <a:bodyPr wrap="square" lIns="0" tIns="0" rIns="0" bIns="0" rtlCol="0" anchor="t"/>
+          <a:lstStyle/>
+          <a:p>
+            <a:pPr marL="0" indent="0">
+              <a:spcAft>
+                <a:spcPts val="200"/>
+              </a:spcAft>
+              <a:buNone/>
+            </a:pPr>
+            <a:r>
+              <a:rPr lang="en-US" sz="1650" b="1" dirty="0">
+                <a:solidFill>
+                  <a:schemeClr val="accent1"/>
+                </a:solidFill>
+              </a:rPr>
+              <a:t>Neighbour warm starts</a:t>
+            </a:r>
+            <a:endParaRPr lang="en-US" sz="1650" dirty="0"/>
+          </a:p>
+        </p:txBody>
+      </p:sp>
+      <p:sp>
+        <p:nvSpPr>
+          <p:cNvPr id="292" name="card-body-292"/>
+          <p:cNvSpPr txBox="1"/>
+          <p:nvPr/>
+        </p:nvSpPr>
+        <p:spPr>
+          <a:xfrm>
+            <a:off x="749808" y="3995928"/>
+            <a:ext cx="3099816" cy="1143000"/>
+          </a:xfrm>
+          <a:prstGeom prst="rect">
+            <a:avLst/>
+          </a:prstGeom>
+          <a:noFill/>
+          <a:ln/>
+        </p:spPr>
+        <p:txBody>
+          <a:bodyPr wrap="square" lIns="0" tIns="0" rIns="0" bIns="0" rtlCol="0" anchor="t"/>
+          <a:lstStyle/>
+          <a:p>
+            <a:pPr marL="0" indent="0">
+              <a:spcAft>
+                <a:spcPts val="200"/>
+              </a:spcAft>
+              <a:buNone/>
+            </a:pPr>
+            <a:r>
+              <a:rPr lang="en-US" sz="1350" dirty="0">
+                <a:solidFill>
+                  <a:schemeClr val="tx1"/>
+                </a:solidFill>
+              </a:rPr>
+              <a:t>Each node tries its solved grid neighbours, nearest first, and is cold-started only if all fail: 2 cold starts on the test grid, down from 47.</a:t>
+            </a:r>
+            <a:endParaRPr lang="en-US" sz="1350" dirty="0"/>
+          </a:p>
+        </p:txBody>
+      </p:sp>
+      <p:sp>
+        <p:nvSpPr>
+          <p:cNvPr id="293" name="card-293"/>
+          <p:cNvSpPr/>
+          <p:nvPr/>
+        </p:nvSpPr>
+        <p:spPr>
+          <a:xfrm>
+            <a:off x="4334255" y="3429000"/>
+            <a:ext cx="3502152" cy="1828800"/>
+          </a:xfrm>
+          <a:prstGeom prst="roundRect">
+            <a:avLst>
+              <a:gd name="adj" fmla="val 6000"/>
+            </a:avLst>
+          </a:prstGeom>
+          <a:solidFill>
+            <a:schemeClr val="bg2"/>
+          </a:solidFill>
+          <a:ln>
+            <a:noFill/>
+          </a:ln>
+        </p:spPr>
+        <p:txBody>
+          <a:bodyPr/>
+          <a:lstStyle/>
+          <a:p>
+            <a:endParaRPr lang="en-IN"/>
+          </a:p>
+        </p:txBody>
+      </p:sp>
+      <p:sp>
+        <p:nvSpPr>
+          <p:cNvPr id="294" name="card-head-294"/>
+          <p:cNvSpPr txBox="1"/>
+          <p:nvPr/>
+        </p:nvSpPr>
+        <p:spPr>
+          <a:xfrm>
+            <a:off x="4535423" y="3593592"/>
+            <a:ext cx="3099816" cy="365760"/>
+          </a:xfrm>
+          <a:prstGeom prst="rect">
+            <a:avLst/>
+          </a:prstGeom>
+          <a:noFill/>
+          <a:ln/>
+        </p:spPr>
+        <p:txBody>
+          <a:bodyPr wrap="square" lIns="0" tIns="0" rIns="0" bIns="0" rtlCol="0" anchor="t"/>
+          <a:lstStyle/>
+          <a:p>
+            <a:pPr marL="0" indent="0">
+              <a:spcAft>
+                <a:spcPts val="200"/>
+              </a:spcAft>
+              <a:buNone/>
+            </a:pPr>
+            <a:r>
+              <a:rPr lang="en-US" sz="1650" b="1" dirty="0">
+                <a:solidFill>
+                  <a:schemeClr val="accent1"/>
+                </a:solidFill>
+              </a:rPr>
+              <a:t>Recovers from errors</a:t>
+            </a:r>
+            <a:endParaRPr lang="en-US" sz="1650" dirty="0"/>
+          </a:p>
+        </p:txBody>
+      </p:sp>
+      <p:sp>
+        <p:nvSpPr>
+          <p:cNvPr id="295" name="card-body-295"/>
+          <p:cNvSpPr txBox="1"/>
+          <p:nvPr/>
+        </p:nvSpPr>
+        <p:spPr>
+          <a:xfrm>
+            <a:off x="4535423" y="3995928"/>
+            <a:ext cx="3099816" cy="1143000"/>
+          </a:xfrm>
+          <a:prstGeom prst="rect">
+            <a:avLst/>
+          </a:prstGeom>
+          <a:noFill/>
+          <a:ln/>
+        </p:spPr>
+        <p:txBody>
+          <a:bodyPr wrap="square" lIns="0" tIns="0" rIns="0" bIns="0" rtlCol="0" anchor="t"/>
+          <a:lstStyle/>
+          <a:p>
+            <a:pPr marL="0" indent="0">
+              <a:spcAft>
+                <a:spcPts val="200"/>
+              </a:spcAft>
+              <a:buNone/>
+            </a:pPr>
+            <a:r>
+              <a:rPr lang="en-US" sz="1350" dirty="0">
+                <a:solidFill>
+                  <a:schemeClr val="tx1"/>
+                </a:solidFill>
+              </a:rPr>
+              <a:t>A PETSc error now rebuilds the solver instead of failing every later node; Ctrl-C stops after the current node and checkpoints.</a:t>
+            </a:r>
+            <a:endParaRPr lang="en-US" sz="1350" dirty="0"/>
+          </a:p>
+        </p:txBody>
+      </p:sp>
+      <p:sp>
+        <p:nvSpPr>
+          <p:cNvPr id="296" name="card-296"/>
+          <p:cNvSpPr/>
+          <p:nvPr/>
+        </p:nvSpPr>
+        <p:spPr>
+          <a:xfrm>
+            <a:off x="8119871" y="3429000"/>
+            <a:ext cx="3502152" cy="1828800"/>
+          </a:xfrm>
+          <a:prstGeom prst="roundRect">
+            <a:avLst>
+              <a:gd name="adj" fmla="val 6000"/>
+            </a:avLst>
+          </a:prstGeom>
+          <a:solidFill>
+            <a:schemeClr val="bg2"/>
+          </a:solidFill>
+          <a:ln>
+            <a:noFill/>
+          </a:ln>
+        </p:spPr>
+        <p:txBody>
+          <a:bodyPr/>
+          <a:lstStyle/>
+          <a:p>
+            <a:endParaRPr lang="en-IN"/>
+          </a:p>
+        </p:txBody>
+      </p:sp>
+      <p:sp>
+        <p:nvSpPr>
+          <p:cNvPr id="297" name="card-head-297"/>
+          <p:cNvSpPr txBox="1"/>
+          <p:nvPr/>
+        </p:nvSpPr>
+        <p:spPr>
+          <a:xfrm>
+            <a:off x="8321040" y="3593592"/>
+            <a:ext cx="3099816" cy="365760"/>
+          </a:xfrm>
+          <a:prstGeom prst="rect">
+            <a:avLst/>
+          </a:prstGeom>
+          <a:noFill/>
+          <a:ln/>
+        </p:spPr>
+        <p:txBody>
+          <a:bodyPr wrap="square" lIns="0" tIns="0" rIns="0" bIns="0" rtlCol="0" anchor="t"/>
+          <a:lstStyle/>
+          <a:p>
+            <a:pPr marL="0" indent="0">
+              <a:spcAft>
+                <a:spcPts val="200"/>
+              </a:spcAft>
+              <a:buNone/>
+            </a:pPr>
+            <a:r>
+              <a:rPr lang="en-US" sz="1650" b="1" dirty="0">
+                <a:solidFill>
+                  <a:schemeClr val="accent1"/>
+                </a:solidFill>
+              </a:rPr>
+              <a:t>Streams large output</a:t>
+            </a:r>
+            <a:endParaRPr lang="en-US" sz="1650" dirty="0"/>
+          </a:p>
+        </p:txBody>
+      </p:sp>
+      <p:sp>
+        <p:nvSpPr>
+          <p:cNvPr id="298" name="card-body-298"/>
+          <p:cNvSpPr txBox="1"/>
+          <p:nvPr/>
+        </p:nvSpPr>
+        <p:spPr>
+          <a:xfrm>
+            <a:off x="8321040" y="3995928"/>
+            <a:ext cx="3099816" cy="1143000"/>
+          </a:xfrm>
+          <a:prstGeom prst="rect">
+            <a:avLst/>
+          </a:prstGeom>
+          <a:noFill/>
+          <a:ln/>
+        </p:spPr>
+        <p:txBody>
+          <a:bodyPr wrap="square" lIns="0" tIns="0" rIns="0" bIns="0" rtlCol="0" anchor="t"/>
+          <a:lstStyle/>
+          <a:p>
+            <a:pPr marL="0" indent="0">
+              <a:spcAft>
+                <a:spcPts val="200"/>
+              </a:spcAft>
+              <a:buNone/>
+            </a:pPr>
+            <a:r>
+              <a:rPr lang="en-US" sz="1350" dirty="0">
+                <a:solidFill>
+                  <a:schemeClr val="tx1"/>
+                </a:solidFill>
+              </a:rPr>
+              <a:t>VTU files are written in chunks with 64-bit headers, so θ on the full 5 M-node grid (about 4 GB) no longer exhausts memory.</a:t>
+            </a:r>
+            <a:endParaRPr lang="en-US" sz="1350" dirty="0"/>
+          </a:p>
+        </p:txBody>
+      </p:sp>
+      <p:sp>
+        <p:nvSpPr>
+          <p:cNvPr id="25" name="Slide Number Placeholder 0"/>
+          <p:cNvSpPr>
+            <a:spLocks noGrp="1"/>
+          </p:cNvSpPr>
+          <p:nvPr>
+            <p:ph type="sldNum" sz="quarter" idx="4294967295"/>
+          </p:nvPr>
+        </p:nvSpPr>
+        <p:spPr>
+          <a:xfrm>
+            <a:off x="11155680" y="6400800"/>
+            <a:ext cx="457200" cy="274320"/>
+          </a:xfrm>
+          <a:prstGeom prst="rect">
+            <a:avLst/>
+          </a:prstGeom>
+          <a:extLst>
+            <a:ext uri="{C572A759-6A51-4108-AA02-DFA0A04FC94B}">
+              <ma14:wrappingTextBoxFlag xmlns="" xmlns:ma14="http://schemas.microsoft.com/office/mac/drawingml/2011/main" val="0"/>
+            </a:ext>
+          </a:extLst>
+        </p:spPr>
+        <p:txBody>
+          <a:bodyPr/>
+          <a:lstStyle>
+            <a:lvl1pPr>
+              <a:defRPr sz="1000">
+                <a:solidFill>
+                  <a:schemeClr val="accent6"/>
+                </a:solidFill>
+              </a:defRPr>
+            </a:lvl1pPr>
+          </a:lstStyle>
+          <a:p>
+            <a:pPr algn="r"/>
+            <a:fld id="{F7021451-1387-4CA6-816F-3879F97B5CBC}" type="slidenum">
+              <a:rPr lang="en-US" b="0"/>
+              <a:t>29</a:t>
+            </a:fld>
+            <a:endParaRPr lang="en-US"/>
           </a:p>
         </p:txBody>
       </p:sp>

</xml_diff>